<commit_message>
BmpMaker: RGB input, adjustable size with live file-size preview
Co-Authored-By: Claude Opus 5.5 <noreply@anthropic.com>
</commit_message>
<xml_diff>
--- a/PPT/03_BMP파일생성.pptx
+++ b/PPT/03_BMP파일생성.pptx
@@ -19,6 +19,7 @@
     <p:sldId id="267" r:id="rId19"/>
     <p:sldId id="268" r:id="rId20"/>
     <p:sldId id="269" r:id="rId21"/>
+    <p:sldId id="270" r:id="rId22"/>
   </p:sldIdLst>
   <p:sldSz cx="12191695" cy="6858000" type="screen4x3"/>
   <p:notesSz cx="6858000" cy="9144000"/>
@@ -3657,7 +3658,7 @@
                 <a:latin typeface="맑은 고딕"/>
                 <a:ea typeface="맑은 고딕"/>
               </a:rPr>
-              <a:t>실행하면 Red · Green · Blue 단색 .bmp 파일을 바이트 단위로 직접 작성</a:t>
+              <a:t>입력한 R · G · B 색상과 크기로 단색 .bmp 파일을 바이트 단위로 직접 작성</a:t>
             </a:r>
           </a:p>
         </p:txBody>
@@ -3671,7 +3672,7 @@
         <p:spPr>
           <a:xfrm>
             <a:off x="822960" y="4754880"/>
-            <a:ext cx="1450848" cy="457200"/>
+            <a:ext cx="1393952" cy="457200"/>
           </a:xfrm>
           <a:prstGeom prst="roundRect">
             <a:avLst>
@@ -3717,7 +3718,7 @@
         <p:spPr>
           <a:xfrm>
             <a:off x="822960" y="4754880"/>
-            <a:ext cx="1450848" cy="457200"/>
+            <a:ext cx="1393952" cy="457200"/>
           </a:xfrm>
           <a:prstGeom prst="rect">
             <a:avLst/>
@@ -3743,7 +3744,7 @@
                 <a:latin typeface="맑은 고딕"/>
                 <a:ea typeface="맑은 고딕"/>
               </a:rPr>
-              <a:t>파일 헤더</a:t>
+              <a:t>RGB 입력</a:t>
             </a:r>
           </a:p>
         </p:txBody>
@@ -3756,7 +3757,7 @@
         </p:nvSpPr>
         <p:spPr>
           <a:xfrm>
-            <a:off x="2502408" y="4754880"/>
+            <a:off x="2445512" y="4754880"/>
             <a:ext cx="1450848" cy="457200"/>
           </a:xfrm>
           <a:prstGeom prst="roundRect">
@@ -3802,7 +3803,7 @@
         </p:nvSpPr>
         <p:spPr>
           <a:xfrm>
-            <a:off x="2502408" y="4754880"/>
+            <a:off x="2445512" y="4754880"/>
             <a:ext cx="1450848" cy="457200"/>
           </a:xfrm>
           <a:prstGeom prst="rect">
@@ -3829,7 +3830,7 @@
                 <a:latin typeface="맑은 고딕"/>
                 <a:ea typeface="맑은 고딕"/>
               </a:rPr>
-              <a:t>정보 헤더</a:t>
+              <a:t>크기 조절</a:t>
             </a:r>
           </a:p>
         </p:txBody>
@@ -3842,7 +3843,7 @@
         </p:nvSpPr>
         <p:spPr>
           <a:xfrm>
-            <a:off x="4181856" y="4754880"/>
+            <a:off x="4124960" y="4754880"/>
             <a:ext cx="1393952" cy="457200"/>
           </a:xfrm>
           <a:prstGeom prst="roundRect">
@@ -3888,7 +3889,7 @@
         </p:nvSpPr>
         <p:spPr>
           <a:xfrm>
-            <a:off x="4181856" y="4754880"/>
+            <a:off x="4124960" y="4754880"/>
             <a:ext cx="1393952" cy="457200"/>
           </a:xfrm>
           <a:prstGeom prst="rect">
@@ -3928,7 +3929,7 @@
         </p:nvSpPr>
         <p:spPr>
           <a:xfrm>
-            <a:off x="5804408" y="4754880"/>
+            <a:off x="5747512" y="4754880"/>
             <a:ext cx="1593088" cy="457200"/>
           </a:xfrm>
           <a:prstGeom prst="roundRect">
@@ -3974,7 +3975,7 @@
         </p:nvSpPr>
         <p:spPr>
           <a:xfrm>
-            <a:off x="5804408" y="4754880"/>
+            <a:off x="5747512" y="4754880"/>
             <a:ext cx="1593088" cy="457200"/>
           </a:xfrm>
           <a:prstGeom prst="rect">
@@ -4139,7 +4140,7 @@
                 <a:latin typeface="맑은 고딕"/>
                 <a:ea typeface="맑은 고딕"/>
               </a:rPr>
-              <a:t>선언한 변수 전체 목록 (1/3)  ·  모두 camelCase</a:t>
+              <a:t>선언한 변수 전체 목록 (1/4)  ·  모두 camelCase</a:t>
             </a:r>
           </a:p>
         </p:txBody>
@@ -5125,7 +5126,7 @@
                 <a:latin typeface="맑은 고딕"/>
                 <a:ea typeface="맑은 고딕"/>
               </a:rPr>
-              <a:t>선언한 변수 전체 목록 (2/3)  ·  모두 camelCase</a:t>
+              <a:t>선언한 변수 전체 목록 (2/4)  ·  모두 camelCase</a:t>
             </a:r>
           </a:p>
         </p:txBody>
@@ -6111,7 +6112,7 @@
                 <a:latin typeface="맑은 고딕"/>
                 <a:ea typeface="맑은 고딕"/>
               </a:rPr>
-              <a:t>선언한 변수 전체 목록 (3/3)  ·  모두 camelCase</a:t>
+              <a:t>선언한 변수 전체 목록 (3/4)  ·  모두 camelCase</a:t>
             </a:r>
           </a:p>
         </p:txBody>
@@ -6546,7 +6547,7 @@
                           <a:latin typeface="Consolas"/>
                           <a:ea typeface="맑은 고딕"/>
                         </a:rPr>
-                        <a:t>outputFolder</a:t>
+                        <a:t>maxPixelSize</a:t>
                       </a:r>
                     </a:p>
                   </a:txBody>
@@ -6569,7 +6570,7 @@
                           <a:latin typeface="맑은 고딕"/>
                           <a:ea typeface="맑은 고딕"/>
                         </a:rPr>
-                        <a:t>readonly string</a:t>
+                        <a:t>const int</a:t>
                       </a:r>
                     </a:p>
                   </a:txBody>
@@ -6592,7 +6593,7 @@
                           <a:latin typeface="맑은 고딕"/>
                           <a:ea typeface="맑은 고딕"/>
                         </a:rPr>
-                        <a:t>필드 · MainWindow</a:t>
+                        <a:t>상수 · MainWindow</a:t>
                       </a:r>
                     </a:p>
                   </a:txBody>
@@ -6615,7 +6616,7 @@
                           <a:latin typeface="맑은 고딕"/>
                           <a:ea typeface="맑은 고딕"/>
                         </a:rPr>
-                        <a:t>결과 BMP 저장 폴더</a:t>
+                        <a:t>가로/세로 최대값 (5000)</a:t>
                       </a:r>
                     </a:p>
                   </a:txBody>
@@ -6638,7 +6639,7 @@
                           <a:latin typeface="맑은 고딕"/>
                           <a:ea typeface="맑은 고딕"/>
                         </a:rPr>
-                        <a:t>output(결과물) + Folder → 경로 종류 표시</a:t>
+                        <a:t>max + Pixel + Size → 무엇의 최대 크기인지 명시</a:t>
                       </a:r>
                     </a:p>
                   </a:txBody>
@@ -6663,7 +6664,7 @@
                           <a:latin typeface="Consolas"/>
                           <a:ea typeface="맑은 고딕"/>
                         </a:rPr>
-                        <a:t>redPath / greenPath / bluePath</a:t>
+                        <a:t>outputFolder</a:t>
                       </a:r>
                     </a:p>
                   </a:txBody>
@@ -6686,7 +6687,7 @@
                           <a:latin typeface="맑은 고딕"/>
                           <a:ea typeface="맑은 고딕"/>
                         </a:rPr>
-                        <a:t>string</a:t>
+                        <a:t>readonly string</a:t>
                       </a:r>
                     </a:p>
                   </a:txBody>
@@ -6709,7 +6710,7 @@
                           <a:latin typeface="맑은 고딕"/>
                           <a:ea typeface="맑은 고딕"/>
                         </a:rPr>
-                        <a:t>지역 · CreateAllBmp</a:t>
+                        <a:t>필드 · MainWindow</a:t>
                       </a:r>
                     </a:p>
                   </a:txBody>
@@ -6732,7 +6733,7 @@
                           <a:latin typeface="맑은 고딕"/>
                           <a:ea typeface="맑은 고딕"/>
                         </a:rPr>
-                        <a:t>색상별 파일 경로</a:t>
+                        <a:t>결과 BMP 저장 폴더</a:t>
                       </a:r>
                     </a:p>
                   </a:txBody>
@@ -6755,7 +6756,7 @@
                           <a:latin typeface="맑은 고딕"/>
                           <a:ea typeface="맑은 고딕"/>
                         </a:rPr>
-                        <a:t>색상 + Path → 3개 파일을 구분</a:t>
+                        <a:t>output(결과물) + Folder → 경로 종류 표시</a:t>
                       </a:r>
                     </a:p>
                   </a:txBody>
@@ -6780,7 +6781,7 @@
                           <a:latin typeface="Consolas"/>
                           <a:ea typeface="맑은 고딕"/>
                         </a:rPr>
-                        <a:t>fileLength</a:t>
+                        <a:t>red / green / blue (UI)</a:t>
                       </a:r>
                     </a:p>
                   </a:txBody>
@@ -6803,7 +6804,7 @@
                           <a:latin typeface="맑은 고딕"/>
                           <a:ea typeface="맑은 고딕"/>
                         </a:rPr>
-                        <a:t>long</a:t>
+                        <a:t>byte (out)</a:t>
                       </a:r>
                     </a:p>
                   </a:txBody>
@@ -6826,7 +6827,7 @@
                           <a:latin typeface="맑은 고딕"/>
                           <a:ea typeface="맑은 고딕"/>
                         </a:rPr>
-                        <a:t>지역 · CreateAllBmp</a:t>
+                        <a:t>out 매개변수 · TryReadInputs</a:t>
                       </a:r>
                     </a:p>
                   </a:txBody>
@@ -6849,7 +6850,7 @@
                           <a:latin typeface="맑은 고딕"/>
                           <a:ea typeface="맑은 고딕"/>
                         </a:rPr>
-                        <a:t>생성된 파일 크기 (byte)</a:t>
+                        <a:t>TextBox에서 읽은 색상 값</a:t>
                       </a:r>
                     </a:p>
                   </a:txBody>
@@ -6872,7 +6873,7 @@
                           <a:latin typeface="맑은 고딕"/>
                           <a:ea typeface="맑은 고딕"/>
                         </a:rPr>
-                        <a:t>FileInfo.Length 속성과 같은 단어</a:t>
+                        <a:t>Save()의 매개변수와 같은 이름 → 값 흐름이 보임</a:t>
                       </a:r>
                     </a:p>
                   </a:txBody>
@@ -6897,7 +6898,7 @@
                           <a:latin typeface="Consolas"/>
                           <a:ea typeface="맑은 고딕"/>
                         </a:rPr>
-                        <a:t>bitmapImage</a:t>
+                        <a:t>isColorValid</a:t>
                       </a:r>
                     </a:p>
                   </a:txBody>
@@ -6920,7 +6921,7 @@
                           <a:latin typeface="맑은 고딕"/>
                           <a:ea typeface="맑은 고딕"/>
                         </a:rPr>
-                        <a:t>BitmapImage</a:t>
+                        <a:t>bool</a:t>
                       </a:r>
                     </a:p>
                   </a:txBody>
@@ -6943,7 +6944,7 @@
                           <a:latin typeface="맑은 고딕"/>
                           <a:ea typeface="맑은 고딕"/>
                         </a:rPr>
-                        <a:t>지역 · LoadImage</a:t>
+                        <a:t>지역 · TryReadInputs</a:t>
                       </a:r>
                     </a:p>
                   </a:txBody>
@@ -6966,7 +6967,7 @@
                           <a:latin typeface="맑은 고딕"/>
                           <a:ea typeface="맑은 고딕"/>
                         </a:rPr>
-                        <a:t>화면에 표시할 이미지 객체</a:t>
+                        <a:t>R·G·B 3개 모두 0~255인지</a:t>
                       </a:r>
                     </a:p>
                   </a:txBody>
@@ -6989,7 +6990,7 @@
                           <a:latin typeface="맑은 고딕"/>
                           <a:ea typeface="맑은 고딕"/>
                         </a:rPr>
-                        <a:t>클래스명을 camelCase로 그대로</a:t>
+                        <a:t>is 접두어 bool + 검사 대상(Color)</a:t>
                       </a:r>
                     </a:p>
                   </a:txBody>
@@ -7057,7 +7058,7 @@
                 <a:latin typeface="맑은 고딕"/>
                 <a:ea typeface="맑은 고딕"/>
               </a:rPr>
-              <a:t>화면 컨트롤 이름 (x:Name)</a:t>
+              <a:t>선언 변수 정리</a:t>
             </a:r>
           </a:p>
         </p:txBody>
@@ -7097,7 +7098,7 @@
                 <a:latin typeface="맑은 고딕"/>
                 <a:ea typeface="맑은 고딕"/>
               </a:rPr>
-              <a:t>XAML에서 선언한 컨트롤 변수 · 의미 + 컨트롤 종류 접미어</a:t>
+              <a:t>선언한 변수 전체 목록 (4/4)  ·  모두 camelCase</a:t>
             </a:r>
           </a:p>
         </p:txBody>
@@ -7152,7 +7153,7 @@
         </p:nvGraphicFramePr>
         <p:xfrm>
           <a:off x="548640" y="1417320"/>
-          <a:ext cx="11064240" cy="4069080"/>
+          <a:ext cx="11064240" cy="2606040"/>
         </p:xfrm>
         <a:graphic>
           <a:graphicData uri="http://schemas.openxmlformats.org/drawingml/2006/table">
@@ -7161,9 +7162,11 @@
                 <a:tableStyleId>{5940675A-B579-460E-94D1-54222C63F5DA}</a:tableStyleId>
               </a:tblPr>
               <a:tblGrid>
-                <a:gridCol w="3108960"/>
-                <a:gridCol w="1737360"/>
-                <a:gridCol w="6217920"/>
+                <a:gridCol w="2057400"/>
+                <a:gridCol w="1691640"/>
+                <a:gridCol w="1920240"/>
+                <a:gridCol w="2468880"/>
+                <a:gridCol w="2926080"/>
               </a:tblGrid>
               <a:tr h="411480">
                 <a:tc>
@@ -7172,14 +7175,14 @@
                     <a:lstStyle/>
                     <a:p>
                       <a:r>
-                        <a:rPr sz="1200" b="1">
+                        <a:rPr sz="1100" b="1">
                           <a:solidFill>
                             <a:srgbClr val="FFFFFF"/>
                           </a:solidFill>
                           <a:latin typeface="맑은 고딕"/>
                           <a:ea typeface="맑은 고딕"/>
                         </a:rPr>
-                        <a:t>컨트롤 이름</a:t>
+                        <a:t>변수명</a:t>
                       </a:r>
                     </a:p>
                   </a:txBody>
@@ -7195,14 +7198,14 @@
                     <a:lstStyle/>
                     <a:p>
                       <a:r>
-                        <a:rPr sz="1200" b="1">
+                        <a:rPr sz="1100" b="1">
                           <a:solidFill>
                             <a:srgbClr val="FFFFFF"/>
                           </a:solidFill>
                           <a:latin typeface="맑은 고딕"/>
                           <a:ea typeface="맑은 고딕"/>
                         </a:rPr>
-                        <a:t>종류</a:t>
+                        <a:t>타입</a:t>
                       </a:r>
                     </a:p>
                   </a:txBody>
@@ -7218,14 +7221,14 @@
                     <a:lstStyle/>
                     <a:p>
                       <a:r>
-                        <a:rPr sz="1200" b="1">
+                        <a:rPr sz="1100" b="1">
                           <a:solidFill>
                             <a:srgbClr val="FFFFFF"/>
                           </a:solidFill>
                           <a:latin typeface="맑은 고딕"/>
                           <a:ea typeface="맑은 고딕"/>
                         </a:rPr>
-                        <a:t>용도</a:t>
+                        <a:t>구분 · 위치</a:t>
                       </a:r>
                     </a:p>
                   </a:txBody>
@@ -7235,22 +7238,68 @@
                     </a:solidFill>
                   </a:tcPr>
                 </a:tc>
+                <a:tc>
+                  <a:txBody>
+                    <a:bodyPr wrap="square"/>
+                    <a:lstStyle/>
+                    <a:p>
+                      <a:r>
+                        <a:rPr sz="1100" b="1">
+                          <a:solidFill>
+                            <a:srgbClr val="FFFFFF"/>
+                          </a:solidFill>
+                          <a:latin typeface="맑은 고딕"/>
+                          <a:ea typeface="맑은 고딕"/>
+                        </a:rPr>
+                        <a:t>역할</a:t>
+                      </a:r>
+                    </a:p>
+                  </a:txBody>
+                  <a:tcPr marL="73152" marR="73152" marT="36576" marB="36576" anchor="ctr">
+                    <a:solidFill>
+                      <a:srgbClr val="6A3FA0"/>
+                    </a:solidFill>
+                  </a:tcPr>
+                </a:tc>
+                <a:tc>
+                  <a:txBody>
+                    <a:bodyPr wrap="square"/>
+                    <a:lstStyle/>
+                    <a:p>
+                      <a:r>
+                        <a:rPr sz="1100" b="1">
+                          <a:solidFill>
+                            <a:srgbClr val="FFFFFF"/>
+                          </a:solidFill>
+                          <a:latin typeface="맑은 고딕"/>
+                          <a:ea typeface="맑은 고딕"/>
+                        </a:rPr>
+                        <a:t>이렇게 지은 이유</a:t>
+                      </a:r>
+                    </a:p>
+                  </a:txBody>
+                  <a:tcPr marL="73152" marR="73152" marT="36576" marB="36576" anchor="ctr">
+                    <a:solidFill>
+                      <a:srgbClr val="6A3FA0"/>
+                    </a:solidFill>
+                  </a:tcPr>
+                </a:tc>
               </a:tr>
-              <a:tr h="457200">
-                <a:tc>
-                  <a:txBody>
-                    <a:bodyPr wrap="square"/>
-                    <a:lstStyle/>
-                    <a:p>
-                      <a:r>
-                        <a:rPr sz="1200" b="1">
+              <a:tr h="548640">
+                <a:tc>
+                  <a:txBody>
+                    <a:bodyPr wrap="square"/>
+                    <a:lstStyle/>
+                    <a:p>
+                      <a:r>
+                        <a:rPr sz="1100" b="1">
                           <a:solidFill>
                             <a:srgbClr val="4E2C7A"/>
                           </a:solidFill>
                           <a:latin typeface="Consolas"/>
                           <a:ea typeface="맑은 고딕"/>
                         </a:rPr>
-                        <a:t>widthTextBox</a:t>
+                        <a:t>isSizeValid</a:t>
                       </a:r>
                     </a:p>
                   </a:txBody>
@@ -7266,14 +7315,14 @@
                     <a:lstStyle/>
                     <a:p>
                       <a:r>
-                        <a:rPr sz="1200" b="0">
+                        <a:rPr sz="1100" b="0">
                           <a:solidFill>
                             <a:srgbClr val="1E2A33"/>
                           </a:solidFill>
                           <a:latin typeface="맑은 고딕"/>
                           <a:ea typeface="맑은 고딕"/>
                         </a:rPr>
-                        <a:t>TextBox</a:t>
+                        <a:t>bool</a:t>
                       </a:r>
                     </a:p>
                   </a:txBody>
@@ -7289,14 +7338,14 @@
                     <a:lstStyle/>
                     <a:p>
                       <a:r>
-                        <a:rPr sz="1200" b="0">
+                        <a:rPr sz="1100" b="0">
                           <a:solidFill>
                             <a:srgbClr val="1E2A33"/>
                           </a:solidFill>
                           <a:latin typeface="맑은 고딕"/>
                           <a:ea typeface="맑은 고딕"/>
                         </a:rPr>
-                        <a:t>가로 픽셀 수 입력 (기본 300)</a:t>
+                        <a:t>지역 · TryReadInputs</a:t>
                       </a:r>
                     </a:p>
                   </a:txBody>
@@ -7306,22 +7355,68 @@
                     </a:solidFill>
                   </a:tcPr>
                 </a:tc>
+                <a:tc>
+                  <a:txBody>
+                    <a:bodyPr wrap="square"/>
+                    <a:lstStyle/>
+                    <a:p>
+                      <a:r>
+                        <a:rPr sz="1100" b="0">
+                          <a:solidFill>
+                            <a:srgbClr val="1E2A33"/>
+                          </a:solidFill>
+                          <a:latin typeface="맑은 고딕"/>
+                          <a:ea typeface="맑은 고딕"/>
+                        </a:rPr>
+                        <a:t>가로·세로가 1~5000인지</a:t>
+                      </a:r>
+                    </a:p>
+                  </a:txBody>
+                  <a:tcPr marL="73152" marR="73152" marT="36576" marB="36576" anchor="ctr">
+                    <a:solidFill>
+                      <a:srgbClr val="FFFFFF"/>
+                    </a:solidFill>
+                  </a:tcPr>
+                </a:tc>
+                <a:tc>
+                  <a:txBody>
+                    <a:bodyPr wrap="square"/>
+                    <a:lstStyle/>
+                    <a:p>
+                      <a:r>
+                        <a:rPr sz="1100" b="0">
+                          <a:solidFill>
+                            <a:srgbClr val="1E2A33"/>
+                          </a:solidFill>
+                          <a:latin typeface="맑은 고딕"/>
+                          <a:ea typeface="맑은 고딕"/>
+                        </a:rPr>
+                        <a:t>is 접두어 bool + 검사 대상(Size)</a:t>
+                      </a:r>
+                    </a:p>
+                  </a:txBody>
+                  <a:tcPr marL="73152" marR="73152" marT="36576" marB="36576" anchor="ctr">
+                    <a:solidFill>
+                      <a:srgbClr val="FFFFFF"/>
+                    </a:solidFill>
+                  </a:tcPr>
+                </a:tc>
               </a:tr>
-              <a:tr h="457200">
-                <a:tc>
-                  <a:txBody>
-                    <a:bodyPr wrap="square"/>
-                    <a:lstStyle/>
-                    <a:p>
-                      <a:r>
-                        <a:rPr sz="1200" b="1">
+              <a:tr h="548640">
+                <a:tc>
+                  <a:txBody>
+                    <a:bodyPr wrap="square"/>
+                    <a:lstStyle/>
+                    <a:p>
+                      <a:r>
+                        <a:rPr sz="1100" b="1">
                           <a:solidFill>
                             <a:srgbClr val="4E2C7A"/>
                           </a:solidFill>
                           <a:latin typeface="Consolas"/>
                           <a:ea typeface="맑은 고딕"/>
                         </a:rPr>
-                        <a:t>heightTextBox</a:t>
+                        <a:t>fileName</a:t>
                       </a:r>
                     </a:p>
                   </a:txBody>
@@ -7337,14 +7432,14 @@
                     <a:lstStyle/>
                     <a:p>
                       <a:r>
-                        <a:rPr sz="1200" b="0">
+                        <a:rPr sz="1100" b="0">
                           <a:solidFill>
                             <a:srgbClr val="1E2A33"/>
                           </a:solidFill>
                           <a:latin typeface="맑은 고딕"/>
                           <a:ea typeface="맑은 고딕"/>
                         </a:rPr>
-                        <a:t>TextBox</a:t>
+                        <a:t>string</a:t>
                       </a:r>
                     </a:p>
                   </a:txBody>
@@ -7360,14 +7455,14 @@
                     <a:lstStyle/>
                     <a:p>
                       <a:r>
-                        <a:rPr sz="1200" b="0">
+                        <a:rPr sz="1100" b="0">
                           <a:solidFill>
                             <a:srgbClr val="1E2A33"/>
                           </a:solidFill>
                           <a:latin typeface="맑은 고딕"/>
                           <a:ea typeface="맑은 고딕"/>
                         </a:rPr>
-                        <a:t>세로 픽셀 수 입력 (기본 200)</a:t>
+                        <a:t>지역 · CreateBmp</a:t>
                       </a:r>
                     </a:p>
                   </a:txBody>
@@ -7377,22 +7472,68 @@
                     </a:solidFill>
                   </a:tcPr>
                 </a:tc>
+                <a:tc>
+                  <a:txBody>
+                    <a:bodyPr wrap="square"/>
+                    <a:lstStyle/>
+                    <a:p>
+                      <a:r>
+                        <a:rPr sz="1100" b="0">
+                          <a:solidFill>
+                            <a:srgbClr val="1E2A33"/>
+                          </a:solidFill>
+                          <a:latin typeface="맑은 고딕"/>
+                          <a:ea typeface="맑은 고딕"/>
+                        </a:rPr>
+                        <a:t>R255_G0_B0_300x200.bmp</a:t>
+                      </a:r>
+                    </a:p>
+                  </a:txBody>
+                  <a:tcPr marL="73152" marR="73152" marT="36576" marB="36576" anchor="ctr">
+                    <a:solidFill>
+                      <a:srgbClr val="F2F4F6"/>
+                    </a:solidFill>
+                  </a:tcPr>
+                </a:tc>
+                <a:tc>
+                  <a:txBody>
+                    <a:bodyPr wrap="square"/>
+                    <a:lstStyle/>
+                    <a:p>
+                      <a:r>
+                        <a:rPr sz="1100" b="0">
+                          <a:solidFill>
+                            <a:srgbClr val="1E2A33"/>
+                          </a:solidFill>
+                          <a:latin typeface="맑은 고딕"/>
+                          <a:ea typeface="맑은 고딕"/>
+                        </a:rPr>
+                        <a:t>폴더 없는 이름만 → filePath와 구분</a:t>
+                      </a:r>
+                    </a:p>
+                  </a:txBody>
+                  <a:tcPr marL="73152" marR="73152" marT="36576" marB="36576" anchor="ctr">
+                    <a:solidFill>
+                      <a:srgbClr val="F2F4F6"/>
+                    </a:solidFill>
+                  </a:tcPr>
+                </a:tc>
               </a:tr>
-              <a:tr h="457200">
-                <a:tc>
-                  <a:txBody>
-                    <a:bodyPr wrap="square"/>
-                    <a:lstStyle/>
-                    <a:p>
-                      <a:r>
-                        <a:rPr sz="1200" b="1">
+              <a:tr h="548640">
+                <a:tc>
+                  <a:txBody>
+                    <a:bodyPr wrap="square"/>
+                    <a:lstStyle/>
+                    <a:p>
+                      <a:r>
+                        <a:rPr sz="1100" b="1">
                           <a:solidFill>
                             <a:srgbClr val="4E2C7A"/>
                           </a:solidFill>
                           <a:latin typeface="Consolas"/>
                           <a:ea typeface="맑은 고딕"/>
                         </a:rPr>
-                        <a:t>createButton</a:t>
+                        <a:t>fileLength</a:t>
                       </a:r>
                     </a:p>
                   </a:txBody>
@@ -7408,14 +7549,14 @@
                     <a:lstStyle/>
                     <a:p>
                       <a:r>
-                        <a:rPr sz="1200" b="0">
+                        <a:rPr sz="1100" b="0">
                           <a:solidFill>
                             <a:srgbClr val="1E2A33"/>
                           </a:solidFill>
                           <a:latin typeface="맑은 고딕"/>
                           <a:ea typeface="맑은 고딕"/>
                         </a:rPr>
-                        <a:t>Button</a:t>
+                        <a:t>long</a:t>
                       </a:r>
                     </a:p>
                   </a:txBody>
@@ -7431,14 +7572,14 @@
                     <a:lstStyle/>
                     <a:p>
                       <a:r>
-                        <a:rPr sz="1200" b="0">
+                        <a:rPr sz="1100" b="0">
                           <a:solidFill>
                             <a:srgbClr val="1E2A33"/>
                           </a:solidFill>
                           <a:latin typeface="맑은 고딕"/>
                           <a:ea typeface="맑은 고딕"/>
                         </a:rPr>
-                        <a:t>입력 크기로 3개 파일 다시 생성</a:t>
+                        <a:t>지역 · CreateBmp</a:t>
                       </a:r>
                     </a:p>
                   </a:txBody>
@@ -7448,22 +7589,68 @@
                     </a:solidFill>
                   </a:tcPr>
                 </a:tc>
+                <a:tc>
+                  <a:txBody>
+                    <a:bodyPr wrap="square"/>
+                    <a:lstStyle/>
+                    <a:p>
+                      <a:r>
+                        <a:rPr sz="1100" b="0">
+                          <a:solidFill>
+                            <a:srgbClr val="1E2A33"/>
+                          </a:solidFill>
+                          <a:latin typeface="맑은 고딕"/>
+                          <a:ea typeface="맑은 고딕"/>
+                        </a:rPr>
+                        <a:t>생성된 파일 크기 (byte)</a:t>
+                      </a:r>
+                    </a:p>
+                  </a:txBody>
+                  <a:tcPr marL="73152" marR="73152" marT="36576" marB="36576" anchor="ctr">
+                    <a:solidFill>
+                      <a:srgbClr val="FFFFFF"/>
+                    </a:solidFill>
+                  </a:tcPr>
+                </a:tc>
+                <a:tc>
+                  <a:txBody>
+                    <a:bodyPr wrap="square"/>
+                    <a:lstStyle/>
+                    <a:p>
+                      <a:r>
+                        <a:rPr sz="1100" b="0">
+                          <a:solidFill>
+                            <a:srgbClr val="1E2A33"/>
+                          </a:solidFill>
+                          <a:latin typeface="맑은 고딕"/>
+                          <a:ea typeface="맑은 고딕"/>
+                        </a:rPr>
+                        <a:t>FileInfo.Length 속성과 같은 단어</a:t>
+                      </a:r>
+                    </a:p>
+                  </a:txBody>
+                  <a:tcPr marL="73152" marR="73152" marT="36576" marB="36576" anchor="ctr">
+                    <a:solidFill>
+                      <a:srgbClr val="FFFFFF"/>
+                    </a:solidFill>
+                  </a:tcPr>
+                </a:tc>
               </a:tr>
-              <a:tr h="457200">
-                <a:tc>
-                  <a:txBody>
-                    <a:bodyPr wrap="square"/>
-                    <a:lstStyle/>
-                    <a:p>
-                      <a:r>
-                        <a:rPr sz="1200" b="1">
+              <a:tr h="548640">
+                <a:tc>
+                  <a:txBody>
+                    <a:bodyPr wrap="square"/>
+                    <a:lstStyle/>
+                    <a:p>
+                      <a:r>
+                        <a:rPr sz="1100" b="1">
                           <a:solidFill>
                             <a:srgbClr val="4E2C7A"/>
                           </a:solidFill>
                           <a:latin typeface="Consolas"/>
                           <a:ea typeface="맑은 고딕"/>
                         </a:rPr>
-                        <a:t>openFolderButton</a:t>
+                        <a:t>bitmapImage</a:t>
                       </a:r>
                     </a:p>
                   </a:txBody>
@@ -7479,14 +7666,14 @@
                     <a:lstStyle/>
                     <a:p>
                       <a:r>
-                        <a:rPr sz="1200" b="0">
+                        <a:rPr sz="1100" b="0">
                           <a:solidFill>
                             <a:srgbClr val="1E2A33"/>
                           </a:solidFill>
                           <a:latin typeface="맑은 고딕"/>
                           <a:ea typeface="맑은 고딕"/>
                         </a:rPr>
-                        <a:t>Button</a:t>
+                        <a:t>BitmapImage</a:t>
                       </a:r>
                     </a:p>
                   </a:txBody>
@@ -7502,14 +7689,14 @@
                     <a:lstStyle/>
                     <a:p>
                       <a:r>
-                        <a:rPr sz="1200" b="0">
+                        <a:rPr sz="1100" b="0">
                           <a:solidFill>
                             <a:srgbClr val="1E2A33"/>
                           </a:solidFill>
                           <a:latin typeface="맑은 고딕"/>
                           <a:ea typeface="맑은 고딕"/>
                         </a:rPr>
-                        <a:t>탐색기로 저장 폴더 열기</a:t>
+                        <a:t>지역 · LoadImage</a:t>
                       </a:r>
                     </a:p>
                   </a:txBody>
@@ -7519,281 +7706,43 @@
                     </a:solidFill>
                   </a:tcPr>
                 </a:tc>
-              </a:tr>
-              <a:tr h="457200">
-                <a:tc>
-                  <a:txBody>
-                    <a:bodyPr wrap="square"/>
-                    <a:lstStyle/>
-                    <a:p>
-                      <a:r>
-                        <a:rPr sz="1200" b="1">
-                          <a:solidFill>
-                            <a:srgbClr val="4E2C7A"/>
-                          </a:solidFill>
-                          <a:latin typeface="Consolas"/>
-                          <a:ea typeface="맑은 고딕"/>
-                        </a:rPr>
-                        <a:t>redImage</a:t>
-                      </a:r>
-                    </a:p>
-                  </a:txBody>
-                  <a:tcPr marL="73152" marR="73152" marT="36576" marB="36576" anchor="ctr">
-                    <a:solidFill>
-                      <a:srgbClr val="FFFFFF"/>
-                    </a:solidFill>
-                  </a:tcPr>
-                </a:tc>
-                <a:tc>
-                  <a:txBody>
-                    <a:bodyPr wrap="square"/>
-                    <a:lstStyle/>
-                    <a:p>
-                      <a:r>
-                        <a:rPr sz="1200" b="0">
+                <a:tc>
+                  <a:txBody>
+                    <a:bodyPr wrap="square"/>
+                    <a:lstStyle/>
+                    <a:p>
+                      <a:r>
+                        <a:rPr sz="1100" b="0">
                           <a:solidFill>
                             <a:srgbClr val="1E2A33"/>
                           </a:solidFill>
                           <a:latin typeface="맑은 고딕"/>
                           <a:ea typeface="맑은 고딕"/>
                         </a:rPr>
-                        <a:t>Image</a:t>
-                      </a:r>
-                    </a:p>
-                  </a:txBody>
-                  <a:tcPr marL="73152" marR="73152" marT="36576" marB="36576" anchor="ctr">
-                    <a:solidFill>
-                      <a:srgbClr val="FFFFFF"/>
-                    </a:solidFill>
-                  </a:tcPr>
-                </a:tc>
-                <a:tc>
-                  <a:txBody>
-                    <a:bodyPr wrap="square"/>
-                    <a:lstStyle/>
-                    <a:p>
-                      <a:r>
-                        <a:rPr sz="1200" b="0">
+                        <a:t>화면에 표시할 이미지 객체</a:t>
+                      </a:r>
+                    </a:p>
+                  </a:txBody>
+                  <a:tcPr marL="73152" marR="73152" marT="36576" marB="36576" anchor="ctr">
+                    <a:solidFill>
+                      <a:srgbClr val="F2F4F6"/>
+                    </a:solidFill>
+                  </a:tcPr>
+                </a:tc>
+                <a:tc>
+                  <a:txBody>
+                    <a:bodyPr wrap="square"/>
+                    <a:lstStyle/>
+                    <a:p>
+                      <a:r>
+                        <a:rPr sz="1100" b="0">
                           <a:solidFill>
                             <a:srgbClr val="1E2A33"/>
                           </a:solidFill>
                           <a:latin typeface="맑은 고딕"/>
                           <a:ea typeface="맑은 고딕"/>
                         </a:rPr>
-                        <a:t>Red.bmp 미리보기</a:t>
-                      </a:r>
-                    </a:p>
-                  </a:txBody>
-                  <a:tcPr marL="73152" marR="73152" marT="36576" marB="36576" anchor="ctr">
-                    <a:solidFill>
-                      <a:srgbClr val="FFFFFF"/>
-                    </a:solidFill>
-                  </a:tcPr>
-                </a:tc>
-              </a:tr>
-              <a:tr h="457200">
-                <a:tc>
-                  <a:txBody>
-                    <a:bodyPr wrap="square"/>
-                    <a:lstStyle/>
-                    <a:p>
-                      <a:r>
-                        <a:rPr sz="1200" b="1">
-                          <a:solidFill>
-                            <a:srgbClr val="4E2C7A"/>
-                          </a:solidFill>
-                          <a:latin typeface="Consolas"/>
-                          <a:ea typeface="맑은 고딕"/>
-                        </a:rPr>
-                        <a:t>greenImage</a:t>
-                      </a:r>
-                    </a:p>
-                  </a:txBody>
-                  <a:tcPr marL="73152" marR="73152" marT="36576" marB="36576" anchor="ctr">
-                    <a:solidFill>
-                      <a:srgbClr val="F2F4F6"/>
-                    </a:solidFill>
-                  </a:tcPr>
-                </a:tc>
-                <a:tc>
-                  <a:txBody>
-                    <a:bodyPr wrap="square"/>
-                    <a:lstStyle/>
-                    <a:p>
-                      <a:r>
-                        <a:rPr sz="1200" b="0">
-                          <a:solidFill>
-                            <a:srgbClr val="1E2A33"/>
-                          </a:solidFill>
-                          <a:latin typeface="맑은 고딕"/>
-                          <a:ea typeface="맑은 고딕"/>
-                        </a:rPr>
-                        <a:t>Image</a:t>
-                      </a:r>
-                    </a:p>
-                  </a:txBody>
-                  <a:tcPr marL="73152" marR="73152" marT="36576" marB="36576" anchor="ctr">
-                    <a:solidFill>
-                      <a:srgbClr val="F2F4F6"/>
-                    </a:solidFill>
-                  </a:tcPr>
-                </a:tc>
-                <a:tc>
-                  <a:txBody>
-                    <a:bodyPr wrap="square"/>
-                    <a:lstStyle/>
-                    <a:p>
-                      <a:r>
-                        <a:rPr sz="1200" b="0">
-                          <a:solidFill>
-                            <a:srgbClr val="1E2A33"/>
-                          </a:solidFill>
-                          <a:latin typeface="맑은 고딕"/>
-                          <a:ea typeface="맑은 고딕"/>
-                        </a:rPr>
-                        <a:t>Green.bmp 미리보기</a:t>
-                      </a:r>
-                    </a:p>
-                  </a:txBody>
-                  <a:tcPr marL="73152" marR="73152" marT="36576" marB="36576" anchor="ctr">
-                    <a:solidFill>
-                      <a:srgbClr val="F2F4F6"/>
-                    </a:solidFill>
-                  </a:tcPr>
-                </a:tc>
-              </a:tr>
-              <a:tr h="457200">
-                <a:tc>
-                  <a:txBody>
-                    <a:bodyPr wrap="square"/>
-                    <a:lstStyle/>
-                    <a:p>
-                      <a:r>
-                        <a:rPr sz="1200" b="1">
-                          <a:solidFill>
-                            <a:srgbClr val="4E2C7A"/>
-                          </a:solidFill>
-                          <a:latin typeface="Consolas"/>
-                          <a:ea typeface="맑은 고딕"/>
-                        </a:rPr>
-                        <a:t>blueImage</a:t>
-                      </a:r>
-                    </a:p>
-                  </a:txBody>
-                  <a:tcPr marL="73152" marR="73152" marT="36576" marB="36576" anchor="ctr">
-                    <a:solidFill>
-                      <a:srgbClr val="FFFFFF"/>
-                    </a:solidFill>
-                  </a:tcPr>
-                </a:tc>
-                <a:tc>
-                  <a:txBody>
-                    <a:bodyPr wrap="square"/>
-                    <a:lstStyle/>
-                    <a:p>
-                      <a:r>
-                        <a:rPr sz="1200" b="0">
-                          <a:solidFill>
-                            <a:srgbClr val="1E2A33"/>
-                          </a:solidFill>
-                          <a:latin typeface="맑은 고딕"/>
-                          <a:ea typeface="맑은 고딕"/>
-                        </a:rPr>
-                        <a:t>Image</a:t>
-                      </a:r>
-                    </a:p>
-                  </a:txBody>
-                  <a:tcPr marL="73152" marR="73152" marT="36576" marB="36576" anchor="ctr">
-                    <a:solidFill>
-                      <a:srgbClr val="FFFFFF"/>
-                    </a:solidFill>
-                  </a:tcPr>
-                </a:tc>
-                <a:tc>
-                  <a:txBody>
-                    <a:bodyPr wrap="square"/>
-                    <a:lstStyle/>
-                    <a:p>
-                      <a:r>
-                        <a:rPr sz="1200" b="0">
-                          <a:solidFill>
-                            <a:srgbClr val="1E2A33"/>
-                          </a:solidFill>
-                          <a:latin typeface="맑은 고딕"/>
-                          <a:ea typeface="맑은 고딕"/>
-                        </a:rPr>
-                        <a:t>Blue.bmp 미리보기</a:t>
-                      </a:r>
-                    </a:p>
-                  </a:txBody>
-                  <a:tcPr marL="73152" marR="73152" marT="36576" marB="36576" anchor="ctr">
-                    <a:solidFill>
-                      <a:srgbClr val="FFFFFF"/>
-                    </a:solidFill>
-                  </a:tcPr>
-                </a:tc>
-              </a:tr>
-              <a:tr h="457200">
-                <a:tc>
-                  <a:txBody>
-                    <a:bodyPr wrap="square"/>
-                    <a:lstStyle/>
-                    <a:p>
-                      <a:r>
-                        <a:rPr sz="1200" b="1">
-                          <a:solidFill>
-                            <a:srgbClr val="4E2C7A"/>
-                          </a:solidFill>
-                          <a:latin typeface="Consolas"/>
-                          <a:ea typeface="맑은 고딕"/>
-                        </a:rPr>
-                        <a:t>statusTextBlock</a:t>
-                      </a:r>
-                    </a:p>
-                  </a:txBody>
-                  <a:tcPr marL="73152" marR="73152" marT="36576" marB="36576" anchor="ctr">
-                    <a:solidFill>
-                      <a:srgbClr val="F2F4F6"/>
-                    </a:solidFill>
-                  </a:tcPr>
-                </a:tc>
-                <a:tc>
-                  <a:txBody>
-                    <a:bodyPr wrap="square"/>
-                    <a:lstStyle/>
-                    <a:p>
-                      <a:r>
-                        <a:rPr sz="1200" b="0">
-                          <a:solidFill>
-                            <a:srgbClr val="1E2A33"/>
-                          </a:solidFill>
-                          <a:latin typeface="맑은 고딕"/>
-                          <a:ea typeface="맑은 고딕"/>
-                        </a:rPr>
-                        <a:t>TextBlock</a:t>
-                      </a:r>
-                    </a:p>
-                  </a:txBody>
-                  <a:tcPr marL="73152" marR="73152" marT="36576" marB="36576" anchor="ctr">
-                    <a:solidFill>
-                      <a:srgbClr val="F2F4F6"/>
-                    </a:solidFill>
-                  </a:tcPr>
-                </a:tc>
-                <a:tc>
-                  <a:txBody>
-                    <a:bodyPr wrap="square"/>
-                    <a:lstStyle/>
-                    <a:p>
-                      <a:r>
-                        <a:rPr sz="1200" b="0">
-                          <a:solidFill>
-                            <a:srgbClr val="1E2A33"/>
-                          </a:solidFill>
-                          <a:latin typeface="맑은 고딕"/>
-                          <a:ea typeface="맑은 고딕"/>
-                        </a:rPr>
-                        <a:t>크기 · 파일 용량 · 저장 경로 표시</a:t>
+                        <a:t>클래스명을 camelCase로 그대로</a:t>
                       </a:r>
                     </a:p>
                   </a:txBody>
@@ -7861,7 +7810,7 @@
                 <a:latin typeface="맑은 고딕"/>
                 <a:ea typeface="맑은 고딕"/>
               </a:rPr>
-              <a:t>동작 확인 순서</a:t>
+              <a:t>화면 컨트롤 이름 (x:Name)</a:t>
             </a:r>
           </a:p>
         </p:txBody>
@@ -7901,7 +7850,7 @@
                 <a:latin typeface="맑은 고딕"/>
                 <a:ea typeface="맑은 고딕"/>
               </a:rPr>
-              <a:t>실행만 하면 파일이 생성되는 것이 요구사항의 핵심</a:t>
+              <a:t>XAML에서 선언한 컨트롤 변수 · 의미 + 컨트롤 종류 접미어</a:t>
             </a:r>
           </a:p>
         </p:txBody>
@@ -7946,6 +7895,1121 @@
           </a:p>
         </p:txBody>
       </p:sp>
+      <p:graphicFrame>
+        <p:nvGraphicFramePr>
+          <p:cNvPr id="5" name="Table 4"/>
+          <p:cNvGraphicFramePr>
+            <a:graphicFrameLocks noGrp="1"/>
+          </p:cNvGraphicFramePr>
+          <p:nvPr/>
+        </p:nvGraphicFramePr>
+        <p:xfrm>
+          <a:off x="548640" y="1417320"/>
+          <a:ext cx="5394960" cy="3154680"/>
+        </p:xfrm>
+        <a:graphic>
+          <a:graphicData uri="http://schemas.openxmlformats.org/drawingml/2006/table">
+            <a:tbl>
+              <a:tblPr firstRow="1" bandRow="1">
+                <a:tableStyleId>{5940675A-B579-460E-94D1-54222C63F5DA}</a:tableStyleId>
+              </a:tblPr>
+              <a:tblGrid>
+                <a:gridCol w="2423160"/>
+                <a:gridCol w="1143000"/>
+                <a:gridCol w="1828800"/>
+              </a:tblGrid>
+              <a:tr h="411480">
+                <a:tc>
+                  <a:txBody>
+                    <a:bodyPr wrap="square"/>
+                    <a:lstStyle/>
+                    <a:p>
+                      <a:r>
+                        <a:rPr sz="1100" b="1">
+                          <a:solidFill>
+                            <a:srgbClr val="FFFFFF"/>
+                          </a:solidFill>
+                          <a:latin typeface="맑은 고딕"/>
+                          <a:ea typeface="맑은 고딕"/>
+                        </a:rPr>
+                        <a:t>컨트롤 이름</a:t>
+                      </a:r>
+                    </a:p>
+                  </a:txBody>
+                  <a:tcPr marL="73152" marR="73152" marT="36576" marB="36576" anchor="ctr">
+                    <a:solidFill>
+                      <a:srgbClr val="6A3FA0"/>
+                    </a:solidFill>
+                  </a:tcPr>
+                </a:tc>
+                <a:tc>
+                  <a:txBody>
+                    <a:bodyPr wrap="square"/>
+                    <a:lstStyle/>
+                    <a:p>
+                      <a:r>
+                        <a:rPr sz="1100" b="1">
+                          <a:solidFill>
+                            <a:srgbClr val="FFFFFF"/>
+                          </a:solidFill>
+                          <a:latin typeface="맑은 고딕"/>
+                          <a:ea typeface="맑은 고딕"/>
+                        </a:rPr>
+                        <a:t>종류</a:t>
+                      </a:r>
+                    </a:p>
+                  </a:txBody>
+                  <a:tcPr marL="73152" marR="73152" marT="36576" marB="36576" anchor="ctr">
+                    <a:solidFill>
+                      <a:srgbClr val="6A3FA0"/>
+                    </a:solidFill>
+                  </a:tcPr>
+                </a:tc>
+                <a:tc>
+                  <a:txBody>
+                    <a:bodyPr wrap="square"/>
+                    <a:lstStyle/>
+                    <a:p>
+                      <a:r>
+                        <a:rPr sz="1100" b="1">
+                          <a:solidFill>
+                            <a:srgbClr val="FFFFFF"/>
+                          </a:solidFill>
+                          <a:latin typeface="맑은 고딕"/>
+                          <a:ea typeface="맑은 고딕"/>
+                        </a:rPr>
+                        <a:t>용도</a:t>
+                      </a:r>
+                    </a:p>
+                  </a:txBody>
+                  <a:tcPr marL="73152" marR="73152" marT="36576" marB="36576" anchor="ctr">
+                    <a:solidFill>
+                      <a:srgbClr val="6A3FA0"/>
+                    </a:solidFill>
+                  </a:tcPr>
+                </a:tc>
+              </a:tr>
+              <a:tr h="457200">
+                <a:tc>
+                  <a:txBody>
+                    <a:bodyPr wrap="square"/>
+                    <a:lstStyle/>
+                    <a:p>
+                      <a:r>
+                        <a:rPr sz="1100" b="1">
+                          <a:solidFill>
+                            <a:srgbClr val="4E2C7A"/>
+                          </a:solidFill>
+                          <a:latin typeface="Consolas"/>
+                          <a:ea typeface="맑은 고딕"/>
+                        </a:rPr>
+                        <a:t>redTextBox</a:t>
+                      </a:r>
+                    </a:p>
+                  </a:txBody>
+                  <a:tcPr marL="73152" marR="73152" marT="36576" marB="36576" anchor="ctr">
+                    <a:solidFill>
+                      <a:srgbClr val="FFFFFF"/>
+                    </a:solidFill>
+                  </a:tcPr>
+                </a:tc>
+                <a:tc>
+                  <a:txBody>
+                    <a:bodyPr wrap="square"/>
+                    <a:lstStyle/>
+                    <a:p>
+                      <a:r>
+                        <a:rPr sz="1100" b="0">
+                          <a:solidFill>
+                            <a:srgbClr val="1E2A33"/>
+                          </a:solidFill>
+                          <a:latin typeface="맑은 고딕"/>
+                          <a:ea typeface="맑은 고딕"/>
+                        </a:rPr>
+                        <a:t>TextBox</a:t>
+                      </a:r>
+                    </a:p>
+                  </a:txBody>
+                  <a:tcPr marL="73152" marR="73152" marT="36576" marB="36576" anchor="ctr">
+                    <a:solidFill>
+                      <a:srgbClr val="FFFFFF"/>
+                    </a:solidFill>
+                  </a:tcPr>
+                </a:tc>
+                <a:tc>
+                  <a:txBody>
+                    <a:bodyPr wrap="square"/>
+                    <a:lstStyle/>
+                    <a:p>
+                      <a:r>
+                        <a:rPr sz="1100" b="0">
+                          <a:solidFill>
+                            <a:srgbClr val="1E2A33"/>
+                          </a:solidFill>
+                          <a:latin typeface="맑은 고딕"/>
+                          <a:ea typeface="맑은 고딕"/>
+                        </a:rPr>
+                        <a:t>R 값 입력 (0~255)</a:t>
+                      </a:r>
+                    </a:p>
+                  </a:txBody>
+                  <a:tcPr marL="73152" marR="73152" marT="36576" marB="36576" anchor="ctr">
+                    <a:solidFill>
+                      <a:srgbClr val="FFFFFF"/>
+                    </a:solidFill>
+                  </a:tcPr>
+                </a:tc>
+              </a:tr>
+              <a:tr h="457200">
+                <a:tc>
+                  <a:txBody>
+                    <a:bodyPr wrap="square"/>
+                    <a:lstStyle/>
+                    <a:p>
+                      <a:r>
+                        <a:rPr sz="1100" b="1">
+                          <a:solidFill>
+                            <a:srgbClr val="4E2C7A"/>
+                          </a:solidFill>
+                          <a:latin typeface="Consolas"/>
+                          <a:ea typeface="맑은 고딕"/>
+                        </a:rPr>
+                        <a:t>greenTextBox</a:t>
+                      </a:r>
+                    </a:p>
+                  </a:txBody>
+                  <a:tcPr marL="73152" marR="73152" marT="36576" marB="36576" anchor="ctr">
+                    <a:solidFill>
+                      <a:srgbClr val="F2F4F6"/>
+                    </a:solidFill>
+                  </a:tcPr>
+                </a:tc>
+                <a:tc>
+                  <a:txBody>
+                    <a:bodyPr wrap="square"/>
+                    <a:lstStyle/>
+                    <a:p>
+                      <a:r>
+                        <a:rPr sz="1100" b="0">
+                          <a:solidFill>
+                            <a:srgbClr val="1E2A33"/>
+                          </a:solidFill>
+                          <a:latin typeface="맑은 고딕"/>
+                          <a:ea typeface="맑은 고딕"/>
+                        </a:rPr>
+                        <a:t>TextBox</a:t>
+                      </a:r>
+                    </a:p>
+                  </a:txBody>
+                  <a:tcPr marL="73152" marR="73152" marT="36576" marB="36576" anchor="ctr">
+                    <a:solidFill>
+                      <a:srgbClr val="F2F4F6"/>
+                    </a:solidFill>
+                  </a:tcPr>
+                </a:tc>
+                <a:tc>
+                  <a:txBody>
+                    <a:bodyPr wrap="square"/>
+                    <a:lstStyle/>
+                    <a:p>
+                      <a:r>
+                        <a:rPr sz="1100" b="0">
+                          <a:solidFill>
+                            <a:srgbClr val="1E2A33"/>
+                          </a:solidFill>
+                          <a:latin typeface="맑은 고딕"/>
+                          <a:ea typeface="맑은 고딕"/>
+                        </a:rPr>
+                        <a:t>G 값 입력 (0~255)</a:t>
+                      </a:r>
+                    </a:p>
+                  </a:txBody>
+                  <a:tcPr marL="73152" marR="73152" marT="36576" marB="36576" anchor="ctr">
+                    <a:solidFill>
+                      <a:srgbClr val="F2F4F6"/>
+                    </a:solidFill>
+                  </a:tcPr>
+                </a:tc>
+              </a:tr>
+              <a:tr h="457200">
+                <a:tc>
+                  <a:txBody>
+                    <a:bodyPr wrap="square"/>
+                    <a:lstStyle/>
+                    <a:p>
+                      <a:r>
+                        <a:rPr sz="1100" b="1">
+                          <a:solidFill>
+                            <a:srgbClr val="4E2C7A"/>
+                          </a:solidFill>
+                          <a:latin typeface="Consolas"/>
+                          <a:ea typeface="맑은 고딕"/>
+                        </a:rPr>
+                        <a:t>blueTextBox</a:t>
+                      </a:r>
+                    </a:p>
+                  </a:txBody>
+                  <a:tcPr marL="73152" marR="73152" marT="36576" marB="36576" anchor="ctr">
+                    <a:solidFill>
+                      <a:srgbClr val="FFFFFF"/>
+                    </a:solidFill>
+                  </a:tcPr>
+                </a:tc>
+                <a:tc>
+                  <a:txBody>
+                    <a:bodyPr wrap="square"/>
+                    <a:lstStyle/>
+                    <a:p>
+                      <a:r>
+                        <a:rPr sz="1100" b="0">
+                          <a:solidFill>
+                            <a:srgbClr val="1E2A33"/>
+                          </a:solidFill>
+                          <a:latin typeface="맑은 고딕"/>
+                          <a:ea typeface="맑은 고딕"/>
+                        </a:rPr>
+                        <a:t>TextBox</a:t>
+                      </a:r>
+                    </a:p>
+                  </a:txBody>
+                  <a:tcPr marL="73152" marR="73152" marT="36576" marB="36576" anchor="ctr">
+                    <a:solidFill>
+                      <a:srgbClr val="FFFFFF"/>
+                    </a:solidFill>
+                  </a:tcPr>
+                </a:tc>
+                <a:tc>
+                  <a:txBody>
+                    <a:bodyPr wrap="square"/>
+                    <a:lstStyle/>
+                    <a:p>
+                      <a:r>
+                        <a:rPr sz="1100" b="0">
+                          <a:solidFill>
+                            <a:srgbClr val="1E2A33"/>
+                          </a:solidFill>
+                          <a:latin typeface="맑은 고딕"/>
+                          <a:ea typeface="맑은 고딕"/>
+                        </a:rPr>
+                        <a:t>B 값 입력 (0~255)</a:t>
+                      </a:r>
+                    </a:p>
+                  </a:txBody>
+                  <a:tcPr marL="73152" marR="73152" marT="36576" marB="36576" anchor="ctr">
+                    <a:solidFill>
+                      <a:srgbClr val="FFFFFF"/>
+                    </a:solidFill>
+                  </a:tcPr>
+                </a:tc>
+              </a:tr>
+              <a:tr h="457200">
+                <a:tc>
+                  <a:txBody>
+                    <a:bodyPr wrap="square"/>
+                    <a:lstStyle/>
+                    <a:p>
+                      <a:r>
+                        <a:rPr sz="1100" b="1">
+                          <a:solidFill>
+                            <a:srgbClr val="4E2C7A"/>
+                          </a:solidFill>
+                          <a:latin typeface="Consolas"/>
+                          <a:ea typeface="맑은 고딕"/>
+                        </a:rPr>
+                        <a:t>colorPreviewBorder</a:t>
+                      </a:r>
+                    </a:p>
+                  </a:txBody>
+                  <a:tcPr marL="73152" marR="73152" marT="36576" marB="36576" anchor="ctr">
+                    <a:solidFill>
+                      <a:srgbClr val="F2F4F6"/>
+                    </a:solidFill>
+                  </a:tcPr>
+                </a:tc>
+                <a:tc>
+                  <a:txBody>
+                    <a:bodyPr wrap="square"/>
+                    <a:lstStyle/>
+                    <a:p>
+                      <a:r>
+                        <a:rPr sz="1100" b="0">
+                          <a:solidFill>
+                            <a:srgbClr val="1E2A33"/>
+                          </a:solidFill>
+                          <a:latin typeface="맑은 고딕"/>
+                          <a:ea typeface="맑은 고딕"/>
+                        </a:rPr>
+                        <a:t>Border</a:t>
+                      </a:r>
+                    </a:p>
+                  </a:txBody>
+                  <a:tcPr marL="73152" marR="73152" marT="36576" marB="36576" anchor="ctr">
+                    <a:solidFill>
+                      <a:srgbClr val="F2F4F6"/>
+                    </a:solidFill>
+                  </a:tcPr>
+                </a:tc>
+                <a:tc>
+                  <a:txBody>
+                    <a:bodyPr wrap="square"/>
+                    <a:lstStyle/>
+                    <a:p>
+                      <a:r>
+                        <a:rPr sz="1100" b="0">
+                          <a:solidFill>
+                            <a:srgbClr val="1E2A33"/>
+                          </a:solidFill>
+                          <a:latin typeface="맑은 고딕"/>
+                          <a:ea typeface="맑은 고딕"/>
+                        </a:rPr>
+                        <a:t>입력한 색상 미리보기</a:t>
+                      </a:r>
+                    </a:p>
+                  </a:txBody>
+                  <a:tcPr marL="73152" marR="73152" marT="36576" marB="36576" anchor="ctr">
+                    <a:solidFill>
+                      <a:srgbClr val="F2F4F6"/>
+                    </a:solidFill>
+                  </a:tcPr>
+                </a:tc>
+              </a:tr>
+              <a:tr h="457200">
+                <a:tc>
+                  <a:txBody>
+                    <a:bodyPr wrap="square"/>
+                    <a:lstStyle/>
+                    <a:p>
+                      <a:r>
+                        <a:rPr sz="1100" b="1">
+                          <a:solidFill>
+                            <a:srgbClr val="4E2C7A"/>
+                          </a:solidFill>
+                          <a:latin typeface="Consolas"/>
+                          <a:ea typeface="맑은 고딕"/>
+                        </a:rPr>
+                        <a:t>widthTextBox</a:t>
+                      </a:r>
+                    </a:p>
+                  </a:txBody>
+                  <a:tcPr marL="73152" marR="73152" marT="36576" marB="36576" anchor="ctr">
+                    <a:solidFill>
+                      <a:srgbClr val="FFFFFF"/>
+                    </a:solidFill>
+                  </a:tcPr>
+                </a:tc>
+                <a:tc>
+                  <a:txBody>
+                    <a:bodyPr wrap="square"/>
+                    <a:lstStyle/>
+                    <a:p>
+                      <a:r>
+                        <a:rPr sz="1100" b="0">
+                          <a:solidFill>
+                            <a:srgbClr val="1E2A33"/>
+                          </a:solidFill>
+                          <a:latin typeface="맑은 고딕"/>
+                          <a:ea typeface="맑은 고딕"/>
+                        </a:rPr>
+                        <a:t>TextBox</a:t>
+                      </a:r>
+                    </a:p>
+                  </a:txBody>
+                  <a:tcPr marL="73152" marR="73152" marT="36576" marB="36576" anchor="ctr">
+                    <a:solidFill>
+                      <a:srgbClr val="FFFFFF"/>
+                    </a:solidFill>
+                  </a:tcPr>
+                </a:tc>
+                <a:tc>
+                  <a:txBody>
+                    <a:bodyPr wrap="square"/>
+                    <a:lstStyle/>
+                    <a:p>
+                      <a:r>
+                        <a:rPr sz="1100" b="0">
+                          <a:solidFill>
+                            <a:srgbClr val="1E2A33"/>
+                          </a:solidFill>
+                          <a:latin typeface="맑은 고딕"/>
+                          <a:ea typeface="맑은 고딕"/>
+                        </a:rPr>
+                        <a:t>가로 픽셀 (기본 300)</a:t>
+                      </a:r>
+                    </a:p>
+                  </a:txBody>
+                  <a:tcPr marL="73152" marR="73152" marT="36576" marB="36576" anchor="ctr">
+                    <a:solidFill>
+                      <a:srgbClr val="FFFFFF"/>
+                    </a:solidFill>
+                  </a:tcPr>
+                </a:tc>
+              </a:tr>
+              <a:tr h="457200">
+                <a:tc>
+                  <a:txBody>
+                    <a:bodyPr wrap="square"/>
+                    <a:lstStyle/>
+                    <a:p>
+                      <a:r>
+                        <a:rPr sz="1100" b="1">
+                          <a:solidFill>
+                            <a:srgbClr val="4E2C7A"/>
+                          </a:solidFill>
+                          <a:latin typeface="Consolas"/>
+                          <a:ea typeface="맑은 고딕"/>
+                        </a:rPr>
+                        <a:t>heightTextBox</a:t>
+                      </a:r>
+                    </a:p>
+                  </a:txBody>
+                  <a:tcPr marL="73152" marR="73152" marT="36576" marB="36576" anchor="ctr">
+                    <a:solidFill>
+                      <a:srgbClr val="F2F4F6"/>
+                    </a:solidFill>
+                  </a:tcPr>
+                </a:tc>
+                <a:tc>
+                  <a:txBody>
+                    <a:bodyPr wrap="square"/>
+                    <a:lstStyle/>
+                    <a:p>
+                      <a:r>
+                        <a:rPr sz="1100" b="0">
+                          <a:solidFill>
+                            <a:srgbClr val="1E2A33"/>
+                          </a:solidFill>
+                          <a:latin typeface="맑은 고딕"/>
+                          <a:ea typeface="맑은 고딕"/>
+                        </a:rPr>
+                        <a:t>TextBox</a:t>
+                      </a:r>
+                    </a:p>
+                  </a:txBody>
+                  <a:tcPr marL="73152" marR="73152" marT="36576" marB="36576" anchor="ctr">
+                    <a:solidFill>
+                      <a:srgbClr val="F2F4F6"/>
+                    </a:solidFill>
+                  </a:tcPr>
+                </a:tc>
+                <a:tc>
+                  <a:txBody>
+                    <a:bodyPr wrap="square"/>
+                    <a:lstStyle/>
+                    <a:p>
+                      <a:r>
+                        <a:rPr sz="1100" b="0">
+                          <a:solidFill>
+                            <a:srgbClr val="1E2A33"/>
+                          </a:solidFill>
+                          <a:latin typeface="맑은 고딕"/>
+                          <a:ea typeface="맑은 고딕"/>
+                        </a:rPr>
+                        <a:t>세로 픽셀 (기본 200)</a:t>
+                      </a:r>
+                    </a:p>
+                  </a:txBody>
+                  <a:tcPr marL="73152" marR="73152" marT="36576" marB="36576" anchor="ctr">
+                    <a:solidFill>
+                      <a:srgbClr val="F2F4F6"/>
+                    </a:solidFill>
+                  </a:tcPr>
+                </a:tc>
+              </a:tr>
+            </a:tbl>
+          </a:graphicData>
+        </a:graphic>
+      </p:graphicFrame>
+      <p:graphicFrame>
+        <p:nvGraphicFramePr>
+          <p:cNvPr id="6" name="Table 5"/>
+          <p:cNvGraphicFramePr>
+            <a:graphicFrameLocks noGrp="1"/>
+          </p:cNvGraphicFramePr>
+          <p:nvPr/>
+        </p:nvGraphicFramePr>
+        <p:xfrm>
+          <a:off x="6217920" y="1417320"/>
+          <a:ext cx="5394960" cy="2697480"/>
+        </p:xfrm>
+        <a:graphic>
+          <a:graphicData uri="http://schemas.openxmlformats.org/drawingml/2006/table">
+            <a:tbl>
+              <a:tblPr firstRow="1" bandRow="1">
+                <a:tableStyleId>{5940675A-B579-460E-94D1-54222C63F5DA}</a:tableStyleId>
+              </a:tblPr>
+              <a:tblGrid>
+                <a:gridCol w="2423160"/>
+                <a:gridCol w="1143000"/>
+                <a:gridCol w="1828800"/>
+              </a:tblGrid>
+              <a:tr h="411480">
+                <a:tc>
+                  <a:txBody>
+                    <a:bodyPr wrap="square"/>
+                    <a:lstStyle/>
+                    <a:p>
+                      <a:r>
+                        <a:rPr sz="1100" b="1">
+                          <a:solidFill>
+                            <a:srgbClr val="FFFFFF"/>
+                          </a:solidFill>
+                          <a:latin typeface="맑은 고딕"/>
+                          <a:ea typeface="맑은 고딕"/>
+                        </a:rPr>
+                        <a:t>컨트롤 이름</a:t>
+                      </a:r>
+                    </a:p>
+                  </a:txBody>
+                  <a:tcPr marL="73152" marR="73152" marT="36576" marB="36576" anchor="ctr">
+                    <a:solidFill>
+                      <a:srgbClr val="6A3FA0"/>
+                    </a:solidFill>
+                  </a:tcPr>
+                </a:tc>
+                <a:tc>
+                  <a:txBody>
+                    <a:bodyPr wrap="square"/>
+                    <a:lstStyle/>
+                    <a:p>
+                      <a:r>
+                        <a:rPr sz="1100" b="1">
+                          <a:solidFill>
+                            <a:srgbClr val="FFFFFF"/>
+                          </a:solidFill>
+                          <a:latin typeface="맑은 고딕"/>
+                          <a:ea typeface="맑은 고딕"/>
+                        </a:rPr>
+                        <a:t>종류</a:t>
+                      </a:r>
+                    </a:p>
+                  </a:txBody>
+                  <a:tcPr marL="73152" marR="73152" marT="36576" marB="36576" anchor="ctr">
+                    <a:solidFill>
+                      <a:srgbClr val="6A3FA0"/>
+                    </a:solidFill>
+                  </a:tcPr>
+                </a:tc>
+                <a:tc>
+                  <a:txBody>
+                    <a:bodyPr wrap="square"/>
+                    <a:lstStyle/>
+                    <a:p>
+                      <a:r>
+                        <a:rPr sz="1100" b="1">
+                          <a:solidFill>
+                            <a:srgbClr val="FFFFFF"/>
+                          </a:solidFill>
+                          <a:latin typeface="맑은 고딕"/>
+                          <a:ea typeface="맑은 고딕"/>
+                        </a:rPr>
+                        <a:t>용도</a:t>
+                      </a:r>
+                    </a:p>
+                  </a:txBody>
+                  <a:tcPr marL="73152" marR="73152" marT="36576" marB="36576" anchor="ctr">
+                    <a:solidFill>
+                      <a:srgbClr val="6A3FA0"/>
+                    </a:solidFill>
+                  </a:tcPr>
+                </a:tc>
+              </a:tr>
+              <a:tr h="457200">
+                <a:tc>
+                  <a:txBody>
+                    <a:bodyPr wrap="square"/>
+                    <a:lstStyle/>
+                    <a:p>
+                      <a:r>
+                        <a:rPr sz="1100" b="1">
+                          <a:solidFill>
+                            <a:srgbClr val="4E2C7A"/>
+                          </a:solidFill>
+                          <a:latin typeface="Consolas"/>
+                          <a:ea typeface="맑은 고딕"/>
+                        </a:rPr>
+                        <a:t>fileSizeTextBlock</a:t>
+                      </a:r>
+                    </a:p>
+                  </a:txBody>
+                  <a:tcPr marL="73152" marR="73152" marT="36576" marB="36576" anchor="ctr">
+                    <a:solidFill>
+                      <a:srgbClr val="FFFFFF"/>
+                    </a:solidFill>
+                  </a:tcPr>
+                </a:tc>
+                <a:tc>
+                  <a:txBody>
+                    <a:bodyPr wrap="square"/>
+                    <a:lstStyle/>
+                    <a:p>
+                      <a:r>
+                        <a:rPr sz="1100" b="0">
+                          <a:solidFill>
+                            <a:srgbClr val="1E2A33"/>
+                          </a:solidFill>
+                          <a:latin typeface="맑은 고딕"/>
+                          <a:ea typeface="맑은 고딕"/>
+                        </a:rPr>
+                        <a:t>TextBlock</a:t>
+                      </a:r>
+                    </a:p>
+                  </a:txBody>
+                  <a:tcPr marL="73152" marR="73152" marT="36576" marB="36576" anchor="ctr">
+                    <a:solidFill>
+                      <a:srgbClr val="FFFFFF"/>
+                    </a:solidFill>
+                  </a:tcPr>
+                </a:tc>
+                <a:tc>
+                  <a:txBody>
+                    <a:bodyPr wrap="square"/>
+                    <a:lstStyle/>
+                    <a:p>
+                      <a:r>
+                        <a:rPr sz="1100" b="0">
+                          <a:solidFill>
+                            <a:srgbClr val="1E2A33"/>
+                          </a:solidFill>
+                          <a:latin typeface="맑은 고딕"/>
+                          <a:ea typeface="맑은 고딕"/>
+                        </a:rPr>
+                        <a:t>예상 파일 크기 표시</a:t>
+                      </a:r>
+                    </a:p>
+                  </a:txBody>
+                  <a:tcPr marL="73152" marR="73152" marT="36576" marB="36576" anchor="ctr">
+                    <a:solidFill>
+                      <a:srgbClr val="FFFFFF"/>
+                    </a:solidFill>
+                  </a:tcPr>
+                </a:tc>
+              </a:tr>
+              <a:tr h="457200">
+                <a:tc>
+                  <a:txBody>
+                    <a:bodyPr wrap="square"/>
+                    <a:lstStyle/>
+                    <a:p>
+                      <a:r>
+                        <a:rPr sz="1100" b="1">
+                          <a:solidFill>
+                            <a:srgbClr val="4E2C7A"/>
+                          </a:solidFill>
+                          <a:latin typeface="Consolas"/>
+                          <a:ea typeface="맑은 고딕"/>
+                        </a:rPr>
+                        <a:t>createButton</a:t>
+                      </a:r>
+                    </a:p>
+                  </a:txBody>
+                  <a:tcPr marL="73152" marR="73152" marT="36576" marB="36576" anchor="ctr">
+                    <a:solidFill>
+                      <a:srgbClr val="F2F4F6"/>
+                    </a:solidFill>
+                  </a:tcPr>
+                </a:tc>
+                <a:tc>
+                  <a:txBody>
+                    <a:bodyPr wrap="square"/>
+                    <a:lstStyle/>
+                    <a:p>
+                      <a:r>
+                        <a:rPr sz="1100" b="0">
+                          <a:solidFill>
+                            <a:srgbClr val="1E2A33"/>
+                          </a:solidFill>
+                          <a:latin typeface="맑은 고딕"/>
+                          <a:ea typeface="맑은 고딕"/>
+                        </a:rPr>
+                        <a:t>Button</a:t>
+                      </a:r>
+                    </a:p>
+                  </a:txBody>
+                  <a:tcPr marL="73152" marR="73152" marT="36576" marB="36576" anchor="ctr">
+                    <a:solidFill>
+                      <a:srgbClr val="F2F4F6"/>
+                    </a:solidFill>
+                  </a:tcPr>
+                </a:tc>
+                <a:tc>
+                  <a:txBody>
+                    <a:bodyPr wrap="square"/>
+                    <a:lstStyle/>
+                    <a:p>
+                      <a:r>
+                        <a:rPr sz="1100" b="0">
+                          <a:solidFill>
+                            <a:srgbClr val="1E2A33"/>
+                          </a:solidFill>
+                          <a:latin typeface="맑은 고딕"/>
+                          <a:ea typeface="맑은 고딕"/>
+                        </a:rPr>
+                        <a:t>BMP 파일 생성</a:t>
+                      </a:r>
+                    </a:p>
+                  </a:txBody>
+                  <a:tcPr marL="73152" marR="73152" marT="36576" marB="36576" anchor="ctr">
+                    <a:solidFill>
+                      <a:srgbClr val="F2F4F6"/>
+                    </a:solidFill>
+                  </a:tcPr>
+                </a:tc>
+              </a:tr>
+              <a:tr h="457200">
+                <a:tc>
+                  <a:txBody>
+                    <a:bodyPr wrap="square"/>
+                    <a:lstStyle/>
+                    <a:p>
+                      <a:r>
+                        <a:rPr sz="1100" b="1">
+                          <a:solidFill>
+                            <a:srgbClr val="4E2C7A"/>
+                          </a:solidFill>
+                          <a:latin typeface="Consolas"/>
+                          <a:ea typeface="맑은 고딕"/>
+                        </a:rPr>
+                        <a:t>openFolderButton</a:t>
+                      </a:r>
+                    </a:p>
+                  </a:txBody>
+                  <a:tcPr marL="73152" marR="73152" marT="36576" marB="36576" anchor="ctr">
+                    <a:solidFill>
+                      <a:srgbClr val="FFFFFF"/>
+                    </a:solidFill>
+                  </a:tcPr>
+                </a:tc>
+                <a:tc>
+                  <a:txBody>
+                    <a:bodyPr wrap="square"/>
+                    <a:lstStyle/>
+                    <a:p>
+                      <a:r>
+                        <a:rPr sz="1100" b="0">
+                          <a:solidFill>
+                            <a:srgbClr val="1E2A33"/>
+                          </a:solidFill>
+                          <a:latin typeface="맑은 고딕"/>
+                          <a:ea typeface="맑은 고딕"/>
+                        </a:rPr>
+                        <a:t>Button</a:t>
+                      </a:r>
+                    </a:p>
+                  </a:txBody>
+                  <a:tcPr marL="73152" marR="73152" marT="36576" marB="36576" anchor="ctr">
+                    <a:solidFill>
+                      <a:srgbClr val="FFFFFF"/>
+                    </a:solidFill>
+                  </a:tcPr>
+                </a:tc>
+                <a:tc>
+                  <a:txBody>
+                    <a:bodyPr wrap="square"/>
+                    <a:lstStyle/>
+                    <a:p>
+                      <a:r>
+                        <a:rPr sz="1100" b="0">
+                          <a:solidFill>
+                            <a:srgbClr val="1E2A33"/>
+                          </a:solidFill>
+                          <a:latin typeface="맑은 고딕"/>
+                          <a:ea typeface="맑은 고딕"/>
+                        </a:rPr>
+                        <a:t>저장 폴더 열기</a:t>
+                      </a:r>
+                    </a:p>
+                  </a:txBody>
+                  <a:tcPr marL="73152" marR="73152" marT="36576" marB="36576" anchor="ctr">
+                    <a:solidFill>
+                      <a:srgbClr val="FFFFFF"/>
+                    </a:solidFill>
+                  </a:tcPr>
+                </a:tc>
+              </a:tr>
+              <a:tr h="457200">
+                <a:tc>
+                  <a:txBody>
+                    <a:bodyPr wrap="square"/>
+                    <a:lstStyle/>
+                    <a:p>
+                      <a:r>
+                        <a:rPr sz="1100" b="1">
+                          <a:solidFill>
+                            <a:srgbClr val="4E2C7A"/>
+                          </a:solidFill>
+                          <a:latin typeface="Consolas"/>
+                          <a:ea typeface="맑은 고딕"/>
+                        </a:rPr>
+                        <a:t>resultImage</a:t>
+                      </a:r>
+                    </a:p>
+                  </a:txBody>
+                  <a:tcPr marL="73152" marR="73152" marT="36576" marB="36576" anchor="ctr">
+                    <a:solidFill>
+                      <a:srgbClr val="F2F4F6"/>
+                    </a:solidFill>
+                  </a:tcPr>
+                </a:tc>
+                <a:tc>
+                  <a:txBody>
+                    <a:bodyPr wrap="square"/>
+                    <a:lstStyle/>
+                    <a:p>
+                      <a:r>
+                        <a:rPr sz="1100" b="0">
+                          <a:solidFill>
+                            <a:srgbClr val="1E2A33"/>
+                          </a:solidFill>
+                          <a:latin typeface="맑은 고딕"/>
+                          <a:ea typeface="맑은 고딕"/>
+                        </a:rPr>
+                        <a:t>Image</a:t>
+                      </a:r>
+                    </a:p>
+                  </a:txBody>
+                  <a:tcPr marL="73152" marR="73152" marT="36576" marB="36576" anchor="ctr">
+                    <a:solidFill>
+                      <a:srgbClr val="F2F4F6"/>
+                    </a:solidFill>
+                  </a:tcPr>
+                </a:tc>
+                <a:tc>
+                  <a:txBody>
+                    <a:bodyPr wrap="square"/>
+                    <a:lstStyle/>
+                    <a:p>
+                      <a:r>
+                        <a:rPr sz="1100" b="0">
+                          <a:solidFill>
+                            <a:srgbClr val="1E2A33"/>
+                          </a:solidFill>
+                          <a:latin typeface="맑은 고딕"/>
+                          <a:ea typeface="맑은 고딕"/>
+                        </a:rPr>
+                        <a:t>생성된 BMP 미리보기</a:t>
+                      </a:r>
+                    </a:p>
+                  </a:txBody>
+                  <a:tcPr marL="73152" marR="73152" marT="36576" marB="36576" anchor="ctr">
+                    <a:solidFill>
+                      <a:srgbClr val="F2F4F6"/>
+                    </a:solidFill>
+                  </a:tcPr>
+                </a:tc>
+              </a:tr>
+              <a:tr h="457200">
+                <a:tc>
+                  <a:txBody>
+                    <a:bodyPr wrap="square"/>
+                    <a:lstStyle/>
+                    <a:p>
+                      <a:r>
+                        <a:rPr sz="1100" b="1">
+                          <a:solidFill>
+                            <a:srgbClr val="4E2C7A"/>
+                          </a:solidFill>
+                          <a:latin typeface="Consolas"/>
+                          <a:ea typeface="맑은 고딕"/>
+                        </a:rPr>
+                        <a:t>statusTextBlock</a:t>
+                      </a:r>
+                    </a:p>
+                  </a:txBody>
+                  <a:tcPr marL="73152" marR="73152" marT="36576" marB="36576" anchor="ctr">
+                    <a:solidFill>
+                      <a:srgbClr val="FFFFFF"/>
+                    </a:solidFill>
+                  </a:tcPr>
+                </a:tc>
+                <a:tc>
+                  <a:txBody>
+                    <a:bodyPr wrap="square"/>
+                    <a:lstStyle/>
+                    <a:p>
+                      <a:r>
+                        <a:rPr sz="1100" b="0">
+                          <a:solidFill>
+                            <a:srgbClr val="1E2A33"/>
+                          </a:solidFill>
+                          <a:latin typeface="맑은 고딕"/>
+                          <a:ea typeface="맑은 고딕"/>
+                        </a:rPr>
+                        <a:t>TextBlock</a:t>
+                      </a:r>
+                    </a:p>
+                  </a:txBody>
+                  <a:tcPr marL="73152" marR="73152" marT="36576" marB="36576" anchor="ctr">
+                    <a:solidFill>
+                      <a:srgbClr val="FFFFFF"/>
+                    </a:solidFill>
+                  </a:tcPr>
+                </a:tc>
+                <a:tc>
+                  <a:txBody>
+                    <a:bodyPr wrap="square"/>
+                    <a:lstStyle/>
+                    <a:p>
+                      <a:r>
+                        <a:rPr sz="1100" b="0">
+                          <a:solidFill>
+                            <a:srgbClr val="1E2A33"/>
+                          </a:solidFill>
+                          <a:latin typeface="맑은 고딕"/>
+                          <a:ea typeface="맑은 고딕"/>
+                        </a:rPr>
+                        <a:t>파일명 · 용량 · 경로 표시</a:t>
+                      </a:r>
+                    </a:p>
+                  </a:txBody>
+                  <a:tcPr marL="73152" marR="73152" marT="36576" marB="36576" anchor="ctr">
+                    <a:solidFill>
+                      <a:srgbClr val="FFFFFF"/>
+                    </a:solidFill>
+                  </a:tcPr>
+                </a:tc>
+              </a:tr>
+            </a:tbl>
+          </a:graphicData>
+        </a:graphic>
+      </p:graphicFrame>
+    </p:spTree>
+  </p:cSld>
+  <p:clrMapOvr>
+    <a:masterClrMapping/>
+  </p:clrMapOvr>
+</p:sld>
+</file>
+
+<file path=ppt/slides/slide15.xml><?xml version="1.0" encoding="utf-8"?>
+<p:sld xmlns:a="http://schemas.openxmlformats.org/drawingml/2006/main" xmlns:p="http://schemas.openxmlformats.org/presentationml/2006/main" xmlns:r="http://schemas.openxmlformats.org/officeDocument/2006/relationships">
+  <p:cSld>
+    <p:spTree>
+      <p:nvGrpSpPr>
+        <p:cNvPr id="1" name=""/>
+        <p:cNvGrpSpPr/>
+        <p:nvPr/>
+      </p:nvGrpSpPr>
+      <p:grpSpPr/>
+      <p:sp>
+        <p:nvSpPr>
+          <p:cNvPr id="2" name="TextBox 1"/>
+          <p:cNvSpPr txBox="1"/>
+          <p:nvPr/>
+        </p:nvSpPr>
+        <p:spPr>
+          <a:xfrm>
+            <a:off x="548640" y="320040"/>
+            <a:ext cx="11064240" cy="640080"/>
+          </a:xfrm>
+          <a:prstGeom prst="rect">
+            <a:avLst/>
+          </a:prstGeom>
+          <a:noFill/>
+        </p:spPr>
+        <p:txBody>
+          <a:bodyPr wrap="square" anchor="ctr" lIns="45720" rIns="45720">
+            <a:spAutoFit/>
+          </a:bodyPr>
+          <a:lstStyle/>
+          <a:p>
+            <a:pPr algn="l">
+              <a:spcAft>
+                <a:spcPts val="400"/>
+              </a:spcAft>
+            </a:pPr>
+            <a:r>
+              <a:rPr sz="3000" b="1">
+                <a:solidFill>
+                  <a:srgbClr val="1E2A33"/>
+                </a:solidFill>
+                <a:latin typeface="맑은 고딕"/>
+                <a:ea typeface="맑은 고딕"/>
+              </a:rPr>
+              <a:t>동작 확인 순서</a:t>
+            </a:r>
+          </a:p>
+        </p:txBody>
+      </p:sp>
+      <p:sp>
+        <p:nvSpPr>
+          <p:cNvPr id="3" name="TextBox 2"/>
+          <p:cNvSpPr txBox="1"/>
+          <p:nvPr/>
+        </p:nvSpPr>
+        <p:spPr>
+          <a:xfrm>
+            <a:off x="548640" y="932688"/>
+            <a:ext cx="11064240" cy="365760"/>
+          </a:xfrm>
+          <a:prstGeom prst="rect">
+            <a:avLst/>
+          </a:prstGeom>
+          <a:noFill/>
+        </p:spPr>
+        <p:txBody>
+          <a:bodyPr wrap="square" anchor="t" lIns="45720" rIns="45720">
+            <a:spAutoFit/>
+          </a:bodyPr>
+          <a:lstStyle/>
+          <a:p>
+            <a:pPr algn="l">
+              <a:spcAft>
+                <a:spcPts val="400"/>
+              </a:spcAft>
+            </a:pPr>
+            <a:r>
+              <a:rPr sz="1400" b="0">
+                <a:solidFill>
+                  <a:srgbClr val="5B6770"/>
+                </a:solidFill>
+                <a:latin typeface="맑은 고딕"/>
+                <a:ea typeface="맑은 고딕"/>
+              </a:rPr>
+              <a:t>RGB 값과 크기를 바꿔 가며 생성 · 파일 크기 확인</a:t>
+            </a:r>
+          </a:p>
+        </p:txBody>
+      </p:sp>
+      <p:sp>
+        <p:nvSpPr>
+          <p:cNvPr id="4" name="TextBox 3"/>
+          <p:cNvSpPr txBox="1"/>
+          <p:nvPr/>
+        </p:nvSpPr>
+        <p:spPr>
+          <a:xfrm>
+            <a:off x="9692640" y="6400800"/>
+            <a:ext cx="2011680" cy="274320"/>
+          </a:xfrm>
+          <a:prstGeom prst="rect">
+            <a:avLst/>
+          </a:prstGeom>
+          <a:noFill/>
+        </p:spPr>
+        <p:txBody>
+          <a:bodyPr wrap="square" anchor="t" lIns="45720" rIns="45720">
+            <a:spAutoFit/>
+          </a:bodyPr>
+          <a:lstStyle/>
+          <a:p>
+            <a:pPr algn="r">
+              <a:spcAft>
+                <a:spcPts val="400"/>
+              </a:spcAft>
+            </a:pPr>
+            <a:r>
+              <a:rPr sz="1000" b="0">
+                <a:solidFill>
+                  <a:srgbClr val="5B6770"/>
+                </a:solidFill>
+                <a:latin typeface="맑은 고딕"/>
+                <a:ea typeface="맑은 고딕"/>
+              </a:rPr>
+              <a:t>03 BMP 파일 생성  |  15</a:t>
+            </a:r>
+          </a:p>
+        </p:txBody>
+      </p:sp>
       <p:sp>
         <p:nvSpPr>
           <p:cNvPr id="5" name="Rounded Rectangle 4"/>
@@ -7955,7 +9019,7 @@
         <p:spPr>
           <a:xfrm>
             <a:off x="548640" y="1554480"/>
-            <a:ext cx="2560320" cy="4389120"/>
+            <a:ext cx="1993392" cy="4389120"/>
           </a:xfrm>
           <a:prstGeom prst="roundRect">
             <a:avLst>
@@ -8054,7 +9118,7 @@
         <p:spPr>
           <a:xfrm>
             <a:off x="777240" y="2468880"/>
-            <a:ext cx="2103120" cy="685800"/>
+            <a:ext cx="1536192" cy="685800"/>
           </a:xfrm>
           <a:prstGeom prst="rect">
             <a:avLst/>
@@ -8094,7 +9158,7 @@
         <p:spPr>
           <a:xfrm>
             <a:off x="777240" y="3200400"/>
-            <a:ext cx="2103120" cy="2651760"/>
+            <a:ext cx="1536192" cy="2651760"/>
           </a:xfrm>
           <a:prstGeom prst="rect">
             <a:avLst/>
@@ -8120,7 +9184,7 @@
                 <a:latin typeface="맑은 고딕"/>
                 <a:ea typeface="맑은 고딕"/>
               </a:rPr>
-              <a:t>창이 뜨자마자 3개 파일 자동 생성</a:t>
+              <a:t>창이 뜨자마자 기본값 (255, 0, 0)</a:t>
             </a:r>
           </a:p>
           <a:p>
@@ -8137,7 +9201,7 @@
                 <a:latin typeface="맑은 고딕"/>
                 <a:ea typeface="맑은 고딕"/>
               </a:rPr>
-              <a:t>미리보기 3칸에 빨강 · 초록 · 파랑 표시</a:t>
+              <a:t>300 x 200 빨강 BMP 자동 생성</a:t>
             </a:r>
           </a:p>
         </p:txBody>
@@ -8150,8 +9214,8 @@
         </p:nvSpPr>
         <p:spPr>
           <a:xfrm>
-            <a:off x="3383279" y="1554480"/>
-            <a:ext cx="2560320" cy="4389120"/>
+            <a:off x="2816352" y="1554480"/>
+            <a:ext cx="1993392" cy="4389120"/>
           </a:xfrm>
           <a:prstGeom prst="roundRect">
             <a:avLst>
@@ -8196,7 +9260,7 @@
         </p:nvSpPr>
         <p:spPr>
           <a:xfrm>
-            <a:off x="3611879" y="1783080"/>
+            <a:off x="3044952" y="1783080"/>
             <a:ext cx="502920" cy="502920"/>
           </a:xfrm>
           <a:prstGeom prst="ellipse">
@@ -8249,8 +9313,8 @@
         </p:nvSpPr>
         <p:spPr>
           <a:xfrm>
-            <a:off x="3611879" y="2468880"/>
-            <a:ext cx="2103120" cy="685800"/>
+            <a:off x="3044952" y="2468880"/>
+            <a:ext cx="1536192" cy="685800"/>
           </a:xfrm>
           <a:prstGeom prst="rect">
             <a:avLst/>
@@ -8276,7 +9340,7 @@
                 <a:latin typeface="맑은 고딕"/>
                 <a:ea typeface="맑은 고딕"/>
               </a:rPr>
-              <a:t>파일 확인</a:t>
+              <a:t>색상 입력</a:t>
             </a:r>
           </a:p>
         </p:txBody>
@@ -8289,8 +9353,8 @@
         </p:nvSpPr>
         <p:spPr>
           <a:xfrm>
-            <a:off x="3611879" y="3200400"/>
-            <a:ext cx="2103120" cy="2651760"/>
+            <a:off x="3044952" y="3200400"/>
+            <a:ext cx="1536192" cy="2651760"/>
           </a:xfrm>
           <a:prstGeom prst="rect">
             <a:avLst/>
@@ -8316,7 +9380,7 @@
                 <a:latin typeface="맑은 고딕"/>
                 <a:ea typeface="맑은 고딕"/>
               </a:rPr>
-              <a:t>[폴더 열기] → BmpOutput 폴더</a:t>
+              <a:t>예) R 255, G 128, B 0 입력</a:t>
             </a:r>
           </a:p>
           <a:p>
@@ -8333,7 +9397,7 @@
                 <a:latin typeface="맑은 고딕"/>
                 <a:ea typeface="맑은 고딕"/>
               </a:rPr>
-              <a:t>파일 크기 180,054 byte 확인</a:t>
+              <a:t>색상 박스가 주황색으로 즉시 변경</a:t>
             </a:r>
           </a:p>
         </p:txBody>
@@ -8346,8 +9410,8 @@
         </p:nvSpPr>
         <p:spPr>
           <a:xfrm>
-            <a:off x="6217919" y="1554480"/>
-            <a:ext cx="2560320" cy="4389120"/>
+            <a:off x="5084064" y="1554480"/>
+            <a:ext cx="1993392" cy="4389120"/>
           </a:xfrm>
           <a:prstGeom prst="roundRect">
             <a:avLst>
@@ -8392,7 +9456,7 @@
         </p:nvSpPr>
         <p:spPr>
           <a:xfrm>
-            <a:off x="6446519" y="1783080"/>
+            <a:off x="5312664" y="1783080"/>
             <a:ext cx="502920" cy="502920"/>
           </a:xfrm>
           <a:prstGeom prst="ellipse">
@@ -8445,8 +9509,8 @@
         </p:nvSpPr>
         <p:spPr>
           <a:xfrm>
-            <a:off x="6446519" y="2468880"/>
-            <a:ext cx="2103120" cy="685800"/>
+            <a:off x="5312664" y="2468880"/>
+            <a:ext cx="1536192" cy="685800"/>
           </a:xfrm>
           <a:prstGeom prst="rect">
             <a:avLst/>
@@ -8472,7 +9536,7 @@
                 <a:latin typeface="맑은 고딕"/>
                 <a:ea typeface="맑은 고딕"/>
               </a:rPr>
-              <a:t>크기 변경</a:t>
+              <a:t>크기 조절</a:t>
             </a:r>
           </a:p>
         </p:txBody>
@@ -8485,8 +9549,8 @@
         </p:nvSpPr>
         <p:spPr>
           <a:xfrm>
-            <a:off x="6446519" y="3200400"/>
-            <a:ext cx="2103120" cy="2651760"/>
+            <a:off x="5312664" y="3200400"/>
+            <a:ext cx="1536192" cy="2651760"/>
           </a:xfrm>
           <a:prstGeom prst="rect">
             <a:avLst/>
@@ -8512,7 +9576,7 @@
                 <a:latin typeface="맑은 고딕"/>
                 <a:ea typeface="맑은 고딕"/>
               </a:rPr>
-              <a:t>가로 101, 세로 50 입력</a:t>
+              <a:t>가로 · 세로 변경 시 예상 파일 크기 실시간 갱신</a:t>
             </a:r>
           </a:p>
           <a:p>
@@ -8529,7 +9593,7 @@
                 <a:latin typeface="맑은 고딕"/>
                 <a:ea typeface="맑은 고딕"/>
               </a:rPr>
-              <a:t>[다시 생성] → 패딩이 생기는 경우 확인</a:t>
+              <a:t>101 x 50 → 15,254 byte (패딩 1)</a:t>
             </a:r>
           </a:p>
         </p:txBody>
@@ -8542,8 +9606,8 @@
         </p:nvSpPr>
         <p:spPr>
           <a:xfrm>
-            <a:off x="9052559" y="1554480"/>
-            <a:ext cx="2560320" cy="4389120"/>
+            <a:off x="7351775" y="1554480"/>
+            <a:ext cx="1993392" cy="4389120"/>
           </a:xfrm>
           <a:prstGeom prst="roundRect">
             <a:avLst>
@@ -8588,7 +9652,7 @@
         </p:nvSpPr>
         <p:spPr>
           <a:xfrm>
-            <a:off x="9281159" y="1783080"/>
+            <a:off x="7580375" y="1783080"/>
             <a:ext cx="502920" cy="502920"/>
           </a:xfrm>
           <a:prstGeom prst="ellipse">
@@ -8641,8 +9705,8 @@
         </p:nvSpPr>
         <p:spPr>
           <a:xfrm>
-            <a:off x="9281159" y="2468880"/>
-            <a:ext cx="2103120" cy="685800"/>
+            <a:off x="7580375" y="2468880"/>
+            <a:ext cx="1536192" cy="685800"/>
           </a:xfrm>
           <a:prstGeom prst="rect">
             <a:avLst/>
@@ -8668,7 +9732,7 @@
                 <a:latin typeface="맑은 고딕"/>
                 <a:ea typeface="맑은 고딕"/>
               </a:rPr>
-              <a:t>검증</a:t>
+              <a:t>생성 · 확인</a:t>
             </a:r>
           </a:p>
         </p:txBody>
@@ -8681,8 +9745,8 @@
         </p:nvSpPr>
         <p:spPr>
           <a:xfrm>
-            <a:off x="9281159" y="3200400"/>
-            <a:ext cx="2103120" cy="2651760"/>
+            <a:off x="7580375" y="3200400"/>
+            <a:ext cx="1536192" cy="2651760"/>
           </a:xfrm>
           <a:prstGeom prst="rect">
             <a:avLst/>
@@ -8708,7 +9772,7 @@
                 <a:latin typeface="맑은 고딕"/>
                 <a:ea typeface="맑은 고딕"/>
               </a:rPr>
-              <a:t>그림판 등 다른 프로그램으로 열기</a:t>
+              <a:t>[BMP 생성] → 미리보기 표시</a:t>
             </a:r>
           </a:p>
           <a:p>
@@ -8725,7 +9789,203 @@
                 <a:latin typeface="맑은 고딕"/>
                 <a:ea typeface="맑은 고딕"/>
               </a:rPr>
-              <a:t>정상 표시 = 헤더 · 패딩이 규격대로</a:t>
+              <a:t>[폴더 열기]에서 실제 크기 = 예상 크기 확인</a:t>
+            </a:r>
+          </a:p>
+        </p:txBody>
+      </p:sp>
+      <p:sp>
+        <p:nvSpPr>
+          <p:cNvPr id="21" name="Rounded Rectangle 20"/>
+          <p:cNvSpPr/>
+          <p:nvPr/>
+        </p:nvSpPr>
+        <p:spPr>
+          <a:xfrm>
+            <a:off x="9619488" y="1554480"/>
+            <a:ext cx="1993392" cy="4389120"/>
+          </a:xfrm>
+          <a:prstGeom prst="roundRect">
+            <a:avLst>
+              <a:gd name="adj" fmla="val 8000"/>
+            </a:avLst>
+          </a:prstGeom>
+          <a:solidFill>
+            <a:srgbClr val="F2F4F6"/>
+          </a:solidFill>
+          <a:ln>
+            <a:noFill/>
+          </a:ln>
+          <a:effectLst/>
+        </p:spPr>
+        <p:style>
+          <a:lnRef idx="1">
+            <a:schemeClr val="accent1"/>
+          </a:lnRef>
+          <a:fillRef idx="3">
+            <a:schemeClr val="accent1"/>
+          </a:fillRef>
+          <a:effectRef idx="2">
+            <a:schemeClr val="accent1"/>
+          </a:effectRef>
+          <a:fontRef idx="minor">
+            <a:schemeClr val="lt1"/>
+          </a:fontRef>
+        </p:style>
+        <p:txBody>
+          <a:bodyPr rtlCol="0" anchor="ctr"/>
+          <a:lstStyle/>
+          <a:p>
+            <a:pPr algn="ctr"/>
+          </a:p>
+        </p:txBody>
+      </p:sp>
+      <p:sp>
+        <p:nvSpPr>
+          <p:cNvPr id="22" name="Oval 21"/>
+          <p:cNvSpPr/>
+          <p:nvPr/>
+        </p:nvSpPr>
+        <p:spPr>
+          <a:xfrm>
+            <a:off x="9848088" y="1783080"/>
+            <a:ext cx="502920" cy="502920"/>
+          </a:xfrm>
+          <a:prstGeom prst="ellipse">
+            <a:avLst/>
+          </a:prstGeom>
+          <a:solidFill>
+            <a:srgbClr val="6A3FA0"/>
+          </a:solidFill>
+          <a:ln>
+            <a:noFill/>
+          </a:ln>
+          <a:effectLst/>
+        </p:spPr>
+        <p:style>
+          <a:lnRef idx="1">
+            <a:schemeClr val="accent1"/>
+          </a:lnRef>
+          <a:fillRef idx="3">
+            <a:schemeClr val="accent1"/>
+          </a:fillRef>
+          <a:effectRef idx="2">
+            <a:schemeClr val="accent1"/>
+          </a:effectRef>
+          <a:fontRef idx="minor">
+            <a:schemeClr val="lt1"/>
+          </a:fontRef>
+        </p:style>
+        <p:txBody>
+          <a:bodyPr rtlCol="0" anchor="ctr" lIns="0" rIns="0" tIns="0" bIns="0"/>
+          <a:lstStyle/>
+          <a:p>
+            <a:pPr algn="ctr"/>
+            <a:r>
+              <a:rPr sz="1600" b="1">
+                <a:solidFill>
+                  <a:srgbClr val="FFFFFF"/>
+                </a:solidFill>
+                <a:latin typeface="맑은 고딕"/>
+              </a:rPr>
+              <a:t>5</a:t>
+            </a:r>
+          </a:p>
+        </p:txBody>
+      </p:sp>
+      <p:sp>
+        <p:nvSpPr>
+          <p:cNvPr id="23" name="TextBox 22"/>
+          <p:cNvSpPr txBox="1"/>
+          <p:nvPr/>
+        </p:nvSpPr>
+        <p:spPr>
+          <a:xfrm>
+            <a:off x="9848088" y="2468880"/>
+            <a:ext cx="1536192" cy="685800"/>
+          </a:xfrm>
+          <a:prstGeom prst="rect">
+            <a:avLst/>
+          </a:prstGeom>
+          <a:noFill/>
+        </p:spPr>
+        <p:txBody>
+          <a:bodyPr wrap="square" anchor="t" lIns="45720" rIns="45720">
+            <a:spAutoFit/>
+          </a:bodyPr>
+          <a:lstStyle/>
+          <a:p>
+            <a:pPr algn="l">
+              <a:spcAft>
+                <a:spcPts val="400"/>
+              </a:spcAft>
+            </a:pPr>
+            <a:r>
+              <a:rPr sz="1600" b="1">
+                <a:solidFill>
+                  <a:srgbClr val="1E2A33"/>
+                </a:solidFill>
+                <a:latin typeface="맑은 고딕"/>
+                <a:ea typeface="맑은 고딕"/>
+              </a:rPr>
+              <a:t>오류 입력</a:t>
+            </a:r>
+          </a:p>
+        </p:txBody>
+      </p:sp>
+      <p:sp>
+        <p:nvSpPr>
+          <p:cNvPr id="24" name="TextBox 23"/>
+          <p:cNvSpPr txBox="1"/>
+          <p:nvPr/>
+        </p:nvSpPr>
+        <p:spPr>
+          <a:xfrm>
+            <a:off x="9848088" y="3200400"/>
+            <a:ext cx="1536192" cy="2651760"/>
+          </a:xfrm>
+          <a:prstGeom prst="rect">
+            <a:avLst/>
+          </a:prstGeom>
+          <a:noFill/>
+        </p:spPr>
+        <p:txBody>
+          <a:bodyPr wrap="square" anchor="t" lIns="45720" rIns="45720">
+            <a:spAutoFit/>
+          </a:bodyPr>
+          <a:lstStyle/>
+          <a:p>
+            <a:pPr algn="l">
+              <a:spcAft>
+                <a:spcPts val="500"/>
+              </a:spcAft>
+            </a:pPr>
+            <a:r>
+              <a:rPr sz="1300" b="0">
+                <a:solidFill>
+                  <a:srgbClr val="1E2A33"/>
+                </a:solidFill>
+                <a:latin typeface="맑은 고딕"/>
+                <a:ea typeface="맑은 고딕"/>
+              </a:rPr>
+              <a:t>R 300 또는 가로 0 입력</a:t>
+            </a:r>
+          </a:p>
+          <a:p>
+            <a:pPr algn="l">
+              <a:spcAft>
+                <a:spcPts val="500"/>
+              </a:spcAft>
+            </a:pPr>
+            <a:r>
+              <a:rPr sz="1300" b="0">
+                <a:solidFill>
+                  <a:srgbClr val="1E2A33"/>
+                </a:solidFill>
+                <a:latin typeface="맑은 고딕"/>
+                <a:ea typeface="맑은 고딕"/>
+              </a:rPr>
+              <a:t>'입력값을 확인하세요' 표시, 생성 차단</a:t>
             </a:r>
           </a:p>
         </p:txBody>
@@ -9002,7 +10262,7 @@
                 <a:latin typeface="맑은 고딕"/>
                 <a:ea typeface="맑은 고딕"/>
               </a:rPr>
-              <a:t>자동 생성</a:t>
+              <a:t>RGB 입력</a:t>
             </a:r>
           </a:p>
         </p:txBody>
@@ -9042,7 +10302,7 @@
                 <a:latin typeface="맑은 고딕"/>
                 <a:ea typeface="맑은 고딕"/>
               </a:rPr>
-              <a:t>창이 뜨면(Loaded) 즉시</a:t>
+              <a:t>R · G · B 값을 각각 0~255로 입력</a:t>
             </a:r>
           </a:p>
           <a:p>
@@ -9059,7 +10319,7 @@
                 <a:latin typeface="맑은 고딕"/>
                 <a:ea typeface="맑은 고딕"/>
               </a:rPr>
-              <a:t>Red.bmp · Green.bmp · Blue.bmp 3개 생성</a:t>
+              <a:t>색상 박스로 입력 색을 즉시 확인</a:t>
             </a:r>
           </a:p>
         </p:txBody>
@@ -9198,7 +10458,7 @@
                 <a:latin typeface="맑은 고딕"/>
                 <a:ea typeface="맑은 고딕"/>
               </a:rPr>
-              <a:t>크기 결정</a:t>
+              <a:t>크기 조절</a:t>
             </a:r>
           </a:p>
         </p:txBody>
@@ -9238,7 +10498,7 @@
                 <a:latin typeface="맑은 고딕"/>
                 <a:ea typeface="맑은 고딕"/>
               </a:rPr>
-              <a:t>기본 300 x 200 픽셀 (24bit)</a:t>
+              <a:t>가로 · 세로(1~5000) 입력</a:t>
             </a:r>
           </a:p>
           <a:p>
@@ -9255,7 +10515,7 @@
                 <a:latin typeface="맑은 고딕"/>
                 <a:ea typeface="맑은 고딕"/>
               </a:rPr>
-              <a:t>가로/세로 입력 후 [다시 생성] 가능</a:t>
+              <a:t>예상 파일 크기(byte) 실시간 표시</a:t>
             </a:r>
           </a:p>
         </p:txBody>
@@ -9394,7 +10654,7 @@
                 <a:latin typeface="맑은 고딕"/>
                 <a:ea typeface="맑은 고딕"/>
               </a:rPr>
-              <a:t>미리보기</a:t>
+              <a:t>파일 생성</a:t>
             </a:r>
           </a:p>
         </p:txBody>
@@ -9434,7 +10694,7 @@
                 <a:latin typeface="맑은 고딕"/>
                 <a:ea typeface="맑은 고딕"/>
               </a:rPr>
-              <a:t>생성된 파일을 다시 읽어 Image에 표시</a:t>
+              <a:t>실행 시 기본값으로 자동 1개 생성</a:t>
             </a:r>
           </a:p>
           <a:p>
@@ -9451,7 +10711,7 @@
                 <a:latin typeface="맑은 고딕"/>
                 <a:ea typeface="맑은 고딕"/>
               </a:rPr>
-              <a:t>파일 크기(byte)와 저장 경로 안내</a:t>
+              <a:t>R255_G0_B0_300x200.bmp 형식 이름</a:t>
             </a:r>
           </a:p>
         </p:txBody>
@@ -9590,7 +10850,7 @@
                 <a:latin typeface="맑은 고딕"/>
                 <a:ea typeface="맑은 고딕"/>
               </a:rPr>
-              <a:t>폴더 열기</a:t>
+              <a:t>미리보기 · 폴더</a:t>
             </a:r>
           </a:p>
         </p:txBody>
@@ -9630,7 +10890,7 @@
                 <a:latin typeface="맑은 고딕"/>
                 <a:ea typeface="맑은 고딕"/>
               </a:rPr>
-              <a:t>실행 폴더\BmpOutput에 저장</a:t>
+              <a:t>생성 파일을 다시 읽어 Image에 표시</a:t>
             </a:r>
           </a:p>
           <a:p>
@@ -9647,7 +10907,7 @@
                 <a:latin typeface="맑은 고딕"/>
                 <a:ea typeface="맑은 고딕"/>
               </a:rPr>
-              <a:t>[폴더 열기]로 탐색기에서 확인</a:t>
+              <a:t>[폴더 열기]로 BmpOutput 확인</a:t>
             </a:r>
           </a:p>
         </p:txBody>
@@ -9813,7 +11073,7 @@
                 <a:latin typeface="맑은 고딕"/>
                 <a:ea typeface="맑은 고딕"/>
               </a:rPr>
-              <a:t>BMP 헤더 + 픽셀 데이터 작성</a:t>
+              <a:t>BMP 헤더 + 픽셀 작성, 크기 계산</a:t>
             </a:r>
           </a:p>
         </p:txBody>
@@ -9893,7 +11153,7 @@
                 <a:latin typeface="맑은 고딕"/>
                 <a:ea typeface="맑은 고딕"/>
               </a:rPr>
-              <a:t>크기 입력 · 미리보기 3칸</a:t>
+              <a:t>RGB · 크기 입력, 미리보기</a:t>
             </a:r>
           </a:p>
         </p:txBody>
@@ -9973,7 +11233,7 @@
                 <a:latin typeface="맑은 고딕"/>
                 <a:ea typeface="맑은 고딕"/>
               </a:rPr>
-              <a:t>생성 호출 · 이미지 로드</a:t>
+              <a:t>입력 검사 · 생성 호출 · 이미지 로드</a:t>
             </a:r>
           </a:p>
         </p:txBody>
@@ -16032,7 +17292,7 @@
                 <a:latin typeface="Consolas"/>
                 <a:ea typeface="맑은 고딕"/>
               </a:rPr>
-              <a:t>int rowSize = (width * 3 + 3) / 4 * 4;</a:t>
+              <a:t>int rowSize = GetRowSize(width); // 4배수 정렬</a:t>
             </a:r>
           </a:p>
           <a:p>
@@ -17837,7 +19097,7 @@
                 <a:latin typeface="맑은 고딕"/>
                 <a:ea typeface="맑은 고딕"/>
               </a:rPr>
-              <a:t>CacheOption.OnLoad</a:t>
+              <a:t>byte.TryParse로 범위 검사?</a:t>
             </a:r>
           </a:p>
         </p:txBody>
@@ -17877,7 +19137,7 @@
                 <a:latin typeface="맑은 고딕"/>
                 <a:ea typeface="맑은 고딕"/>
               </a:rPr>
-              <a:t>기본값은 파일을 열어둔 채 지연 로딩 → 같은 파일을 다시 쓰면 '사용 중' 오류. OnLoad는 다 읽고 즉시 닫음.</a:t>
+              <a:t>byte는 0~255만 저장 가능 → 256 이상이나 음수는 변환 자체가 실패. 별도의 if 범위 검사 없이 RGB 입력값 검증.</a:t>
             </a:r>
           </a:p>
         </p:txBody>
@@ -18592,8 +19852,8 @@
               </a:rPr>
               <a:t>static class BmpWriter
 Save()
-CreateAllBmp()
-LoadImage()</a:t>
+CalculateFileSize()
+TryReadInputs()</a:t>
             </a:r>
           </a:p>
         </p:txBody>
@@ -18879,10 +20139,10 @@
                 <a:latin typeface="Consolas"/>
                 <a:ea typeface="맑은 고딕"/>
               </a:rPr>
-              <a:t>widthTextBox
-createButton
-redImage
-statusTextBlock</a:t>
+              <a:t>redTextBox
+widthTextBox
+colorPreviewBorder
+resultImage</a:t>
             </a:r>
           </a:p>
         </p:txBody>

</xml_diff>